<commit_message>
Deck: make slide 6 clearly show the database
Title it "The database: one row per term", name the Supabase table
glossary_terms, and label the grid as column / row 1 / row 2.

Co-Authored-By: Claude Opus 5.5 <noreply@anthropic.com>
Claude-Session: https://claude.ai/code/session_01Sc6RkpjCNnA9gTjSdaAsnK
</commit_message>
<xml_diff>
--- a/presentation/plainly-deck.pptx
+++ b/presentation/plainly-deck.pptx
@@ -966,11 +966,11 @@
           <a:p>
             <a:r>
               <a:rPr lang="en-US" dirty="0"/>
-              <a:t>One Supabase table, glossary_terms. Each row is one medical term: term, search_count, explanation (the reviewed answer plus what the reviewer found, as JSON), model (which AI wrote it, e.g. @cf/meta/llama-3.3-70b-instruct-fp8-fast), prompt_version (old answers are redone when the instructions change), and two timestamps.
+              <a:t>The whole database is one Supabase table, glossary_terms. Each row is one medical term: term, search_count, explanation (the reviewed answer plus what the reviewer found, as JSON), model (which AI wrote it, e.g. @cf/meta/llama-3.3-70b-instruct-fp8-fast), prompt_version (old answers are redone when the instructions change), and two timestamps.
 Row 1: a real answer from the live site (hyponatremia, reviewed by gpt-oss-120b).
 Row 2: what happens with “potassium 5.8 mmol/L”: the answer may mention that number, so only the term is counted and no explanation is saved.
 The search counts shown are examples, not live numbers.
-Privacy: anyone can read the glossary, but only the server can write to it (row-level security), and there is no column for a user, IP address or the text someone typed.
+Privacy: anyone can read the glossary, but only the server can write to it (row-level security), and there is no column for a user, their IP address, or the text someone typed.
 Source: project code, supabase/migrations/0001_glossary.sql and src/worker.js.</a:t>
             </a:r>
             <a:endParaRPr lang="en-US" dirty="0"/>
@@ -3882,9 +3882,59 @@
                   <a:schemeClr val="tx1"/>
                 </a:solidFill>
               </a:rPr>
-              <a:t>It stores the term, never the person</a:t>
+              <a:t>The database: one row per term</a:t>
             </a:r>
             <a:endParaRPr lang="en-US" sz="4000" dirty="0"/>
+          </a:p>
+        </p:txBody>
+      </p:sp>
+      <p:sp>
+        <p:nvSpPr>
+          <p:cNvPr id="3" name="Table name"/>
+          <p:cNvSpPr txBox="1"/>
+          <p:nvPr/>
+        </p:nvSpPr>
+        <p:spPr>
+          <a:xfrm>
+            <a:off x="548640" y="1325880"/>
+            <a:ext cx="11094415" cy="502920"/>
+          </a:xfrm>
+          <a:prstGeom prst="rect">
+            <a:avLst/>
+          </a:prstGeom>
+          <a:noFill/>
+          <a:ln/>
+        </p:spPr>
+        <p:txBody>
+          <a:bodyPr wrap="square" lIns="0" tIns="0" rIns="0" bIns="0" rtlCol="0" anchor="ctr"/>
+          <a:lstStyle/>
+          <a:p>
+            <a:pPr indent="0" marL="0">
+              <a:buNone/>
+            </a:pPr>
+            <a:r>
+              <a:rPr lang="en-US" sz="3200" dirty="0">
+                <a:solidFill>
+                  <a:schemeClr val="tx1"/>
+                </a:solidFill>
+              </a:rPr>
+              <a:t>Supabase table: </a:t>
+            </a:r>
+            <a:pPr indent="0" marL="0">
+              <a:buNone/>
+            </a:pPr>
+            <a:r>
+              <a:rPr lang="en-US" sz="3200" dirty="0">
+                <a:solidFill>
+                  <a:schemeClr val="tx1"/>
+                </a:solidFill>
+                <a:latin typeface="Courier New" pitchFamily="34" charset="0"/>
+                <a:ea typeface="Courier New" pitchFamily="34" charset="-122"/>
+                <a:cs typeface="Courier New" pitchFamily="34" charset="-120"/>
+              </a:rPr>
+              <a:t>glossary_terms</a:t>
+            </a:r>
+            <a:endParaRPr lang="en-US" sz="3200" dirty="0"/>
           </a:p>
         </p:txBody>
       </p:sp>
@@ -3903,7 +3953,7 @@
           </p:nvPr>
         </p:nvGraphicFramePr>
         <p:xfrm>
-          <a:off x="548640" y="1417320"/>
+          <a:off x="548640" y="1965960"/>
           <a:ext cx="11094415" cy="914400"/>
         </p:xfrm>
         <a:graphic>
@@ -3915,6 +3965,191 @@
                 <a:gridCol w="4023360"/>
                 <a:gridCol w="3867912"/>
               </a:tblGrid>
+              <a:tr h="0">
+                <a:tc>
+                  <a:txBody>
+                    <a:bodyPr/>
+                    <a:lstStyle/>
+                    <a:p>
+                      <a:pPr indent="0" marL="0">
+                        <a:buNone/>
+                      </a:pPr>
+                      <a:r>
+                        <a:rPr lang="en-US" sz="3200" b="1" dirty="0">
+                          <a:solidFill>
+                            <a:schemeClr val="tx2"/>
+                          </a:solidFill>
+                        </a:rPr>
+                        <a:t>column</a:t>
+                      </a:r>
+                      <a:endParaRPr lang="en-US" sz="3200" dirty="0"/>
+                    </a:p>
+                  </a:txBody>
+                  <a:tcPr marL="109728" marR="109728" marT="54864" marB="54864" anchor="ctr">
+                    <a:lnL w="12700" cap="flat" cmpd="sng" algn="ctr">
+                      <a:solidFill>
+                        <a:srgbClr val="DDE3E0"/>
+                      </a:solidFill>
+                      <a:prstDash val="solid"/>
+                      <a:round/>
+                      <a:headEnd type="none" w="med" len="med"/>
+                      <a:tailEnd type="none" w="med" len="med"/>
+                    </a:lnL>
+                    <a:lnR w="12700" cap="flat" cmpd="sng" algn="ctr">
+                      <a:solidFill>
+                        <a:srgbClr val="DDE3E0"/>
+                      </a:solidFill>
+                      <a:prstDash val="solid"/>
+                      <a:round/>
+                      <a:headEnd type="none" w="med" len="med"/>
+                      <a:tailEnd type="none" w="med" len="med"/>
+                    </a:lnR>
+                    <a:lnT w="12700" cap="flat" cmpd="sng" algn="ctr">
+                      <a:solidFill>
+                        <a:srgbClr val="DDE3E0"/>
+                      </a:solidFill>
+                      <a:prstDash val="solid"/>
+                      <a:round/>
+                      <a:headEnd type="none" w="med" len="med"/>
+                      <a:tailEnd type="none" w="med" len="med"/>
+                    </a:lnT>
+                    <a:lnB w="12700" cap="flat" cmpd="sng" algn="ctr">
+                      <a:solidFill>
+                        <a:srgbClr val="DDE3E0"/>
+                      </a:solidFill>
+                      <a:prstDash val="solid"/>
+                      <a:round/>
+                      <a:headEnd type="none" w="med" len="med"/>
+                      <a:tailEnd type="none" w="med" len="med"/>
+                    </a:lnB>
+                    <a:solidFill>
+                      <a:schemeClr val="bg1"/>
+                    </a:solidFill>
+                  </a:tcPr>
+                </a:tc>
+                <a:tc>
+                  <a:txBody>
+                    <a:bodyPr/>
+                    <a:lstStyle/>
+                    <a:p>
+                      <a:pPr indent="0" marL="0">
+                        <a:buNone/>
+                      </a:pPr>
+                      <a:r>
+                        <a:rPr lang="en-US" sz="3200" b="1" dirty="0">
+                          <a:solidFill>
+                            <a:schemeClr val="tx2"/>
+                          </a:solidFill>
+                        </a:rPr>
+                        <a:t>row 1</a:t>
+                      </a:r>
+                      <a:endParaRPr lang="en-US" sz="3200" dirty="0"/>
+                    </a:p>
+                  </a:txBody>
+                  <a:tcPr marL="109728" marR="109728" marT="54864" marB="54864" anchor="ctr">
+                    <a:lnL w="12700" cap="flat" cmpd="sng" algn="ctr">
+                      <a:solidFill>
+                        <a:srgbClr val="DDE3E0"/>
+                      </a:solidFill>
+                      <a:prstDash val="solid"/>
+                      <a:round/>
+                      <a:headEnd type="none" w="med" len="med"/>
+                      <a:tailEnd type="none" w="med" len="med"/>
+                    </a:lnL>
+                    <a:lnR w="12700" cap="flat" cmpd="sng" algn="ctr">
+                      <a:solidFill>
+                        <a:srgbClr val="DDE3E0"/>
+                      </a:solidFill>
+                      <a:prstDash val="solid"/>
+                      <a:round/>
+                      <a:headEnd type="none" w="med" len="med"/>
+                      <a:tailEnd type="none" w="med" len="med"/>
+                    </a:lnR>
+                    <a:lnT w="12700" cap="flat" cmpd="sng" algn="ctr">
+                      <a:solidFill>
+                        <a:srgbClr val="DDE3E0"/>
+                      </a:solidFill>
+                      <a:prstDash val="solid"/>
+                      <a:round/>
+                      <a:headEnd type="none" w="med" len="med"/>
+                      <a:tailEnd type="none" w="med" len="med"/>
+                    </a:lnT>
+                    <a:lnB w="12700" cap="flat" cmpd="sng" algn="ctr">
+                      <a:solidFill>
+                        <a:srgbClr val="DDE3E0"/>
+                      </a:solidFill>
+                      <a:prstDash val="solid"/>
+                      <a:round/>
+                      <a:headEnd type="none" w="med" len="med"/>
+                      <a:tailEnd type="none" w="med" len="med"/>
+                    </a:lnB>
+                    <a:solidFill>
+                      <a:schemeClr val="bg1"/>
+                    </a:solidFill>
+                  </a:tcPr>
+                </a:tc>
+                <a:tc>
+                  <a:txBody>
+                    <a:bodyPr/>
+                    <a:lstStyle/>
+                    <a:p>
+                      <a:pPr indent="0" marL="0">
+                        <a:buNone/>
+                      </a:pPr>
+                      <a:r>
+                        <a:rPr lang="en-US" sz="3200" b="1" dirty="0">
+                          <a:solidFill>
+                            <a:schemeClr val="tx2"/>
+                          </a:solidFill>
+                        </a:rPr>
+                        <a:t>row 2</a:t>
+                      </a:r>
+                      <a:endParaRPr lang="en-US" sz="3200" dirty="0"/>
+                    </a:p>
+                  </a:txBody>
+                  <a:tcPr marL="109728" marR="109728" marT="54864" marB="54864" anchor="ctr">
+                    <a:lnL w="12700" cap="flat" cmpd="sng" algn="ctr">
+                      <a:solidFill>
+                        <a:srgbClr val="DDE3E0"/>
+                      </a:solidFill>
+                      <a:prstDash val="solid"/>
+                      <a:round/>
+                      <a:headEnd type="none" w="med" len="med"/>
+                      <a:tailEnd type="none" w="med" len="med"/>
+                    </a:lnL>
+                    <a:lnR w="12700" cap="flat" cmpd="sng" algn="ctr">
+                      <a:solidFill>
+                        <a:srgbClr val="DDE3E0"/>
+                      </a:solidFill>
+                      <a:prstDash val="solid"/>
+                      <a:round/>
+                      <a:headEnd type="none" w="med" len="med"/>
+                      <a:tailEnd type="none" w="med" len="med"/>
+                    </a:lnR>
+                    <a:lnT w="12700" cap="flat" cmpd="sng" algn="ctr">
+                      <a:solidFill>
+                        <a:srgbClr val="DDE3E0"/>
+                      </a:solidFill>
+                      <a:prstDash val="solid"/>
+                      <a:round/>
+                      <a:headEnd type="none" w="med" len="med"/>
+                      <a:tailEnd type="none" w="med" len="med"/>
+                    </a:lnT>
+                    <a:lnB w="12700" cap="flat" cmpd="sng" algn="ctr">
+                      <a:solidFill>
+                        <a:srgbClr val="DDE3E0"/>
+                      </a:solidFill>
+                      <a:prstDash val="solid"/>
+                      <a:round/>
+                      <a:headEnd type="none" w="med" len="med"/>
+                      <a:tailEnd type="none" w="med" len="med"/>
+                    </a:lnB>
+                    <a:solidFill>
+                      <a:schemeClr val="bg1"/>
+                    </a:solidFill>
+                  </a:tcPr>
+                </a:tc>
+              </a:tr>
               <a:tr h="0">
                 <a:tc>
                   <a:txBody>
@@ -4703,14 +4938,14 @@
       </p:graphicFrame>
       <p:sp>
         <p:nvSpPr>
-          <p:cNvPr id="4" name="Never stored"/>
+          <p:cNvPr id="5" name="Never stored"/>
           <p:cNvSpPr txBox="1"/>
           <p:nvPr/>
         </p:nvSpPr>
         <p:spPr>
           <a:xfrm>
-            <a:off x="548640" y="5440680"/>
-            <a:ext cx="11094415" cy="1005840"/>
+            <a:off x="548640" y="5943600"/>
+            <a:ext cx="11094415" cy="502920"/>
           </a:xfrm>
           <a:prstGeom prst="rect">
             <a:avLst/>
@@ -4719,7 +4954,7 @@
           <a:ln/>
         </p:spPr>
         <p:txBody>
-          <a:bodyPr wrap="square" lIns="0" tIns="0" rIns="0" bIns="0" rtlCol="0" anchor="t"/>
+          <a:bodyPr wrap="square" lIns="0" tIns="0" rIns="0" bIns="0" rtlCol="0" anchor="ctr"/>
           <a:lstStyle/>
           <a:p>
             <a:pPr indent="0" marL="0">
@@ -4742,7 +4977,7 @@
                   <a:schemeClr val="tx1"/>
                 </a:solidFill>
               </a:rPr>
-              <a:t>who searched, their IP address, or what they typed</a:t>
+              <a:t>who searched or what they typed</a:t>
             </a:r>
             <a:endParaRPr lang="en-US" sz="3200" dirty="0"/>
           </a:p>

</xml_diff>

<commit_message>
Deck: lay out slide 6 like the real table (columns across, rows down)
Co-Authored-By: Claude Opus 5.5 <noreply@anthropic.com>
Claude-Session: https://claude.ai/code/session_01Sc6RkpjCNnA9gTjSdaAsnK
</commit_message>
<xml_diff>
--- a/presentation/plainly-deck.pptx
+++ b/presentation/plainly-deck.pptx
@@ -3961,9 +3961,10 @@
             <a:tbl>
               <a:tblPr/>
               <a:tblGrid>
-                <a:gridCol w="3200400"/>
-                <a:gridCol w="4023360"/>
-                <a:gridCol w="3867912"/>
+                <a:gridCol w="2788920"/>
+                <a:gridCol w="3154680"/>
+                <a:gridCol w="3090672"/>
+                <a:gridCol w="2057400"/>
               </a:tblGrid>
               <a:tr h="0">
                 <a:tc>
@@ -3977,12 +3978,19 @@
                       <a:r>
                         <a:rPr lang="en-US" sz="3200" b="1" dirty="0">
                           <a:solidFill>
-                            <a:schemeClr val="tx2"/>
+                            <a:schemeClr val="tx1"/>
                           </a:solidFill>
+                          <a:latin typeface="Courier New" pitchFamily="34" charset="0"/>
+                          <a:ea typeface="Courier New" pitchFamily="34" charset="-122"/>
+                          <a:cs typeface="Courier New" pitchFamily="34" charset="-120"/>
                         </a:rPr>
-                        <a:t>column</a:t>
+                        <a:t>term</a:t>
                       </a:r>
-                      <a:endParaRPr lang="en-US" sz="3200" dirty="0"/>
+                      <a:endParaRPr lang="en-US" sz="3200" dirty="0">
+                        <a:latin typeface="Courier New" charset="0"/>
+                        <a:ea typeface="Courier New" charset="0"/>
+                        <a:cs typeface="Courier New" charset="0"/>
+                      </a:endParaRPr>
                     </a:p>
                   </a:txBody>
                   <a:tcPr marL="109728" marR="109728" marT="54864" marB="54864" anchor="ctr">
@@ -4038,12 +4046,19 @@
                       <a:r>
                         <a:rPr lang="en-US" sz="3200" b="1" dirty="0">
                           <a:solidFill>
-                            <a:schemeClr val="tx2"/>
+                            <a:schemeClr val="tx1"/>
                           </a:solidFill>
+                          <a:latin typeface="Courier New" pitchFamily="34" charset="0"/>
+                          <a:ea typeface="Courier New" pitchFamily="34" charset="-122"/>
+                          <a:cs typeface="Courier New" pitchFamily="34" charset="-120"/>
                         </a:rPr>
-                        <a:t>row 1</a:t>
+                        <a:t>search_count</a:t>
                       </a:r>
-                      <a:endParaRPr lang="en-US" sz="3200" dirty="0"/>
+                      <a:endParaRPr lang="en-US" sz="3200" dirty="0">
+                        <a:latin typeface="Courier New" charset="0"/>
+                        <a:ea typeface="Courier New" charset="0"/>
+                        <a:cs typeface="Courier New" charset="0"/>
+                      </a:endParaRPr>
                     </a:p>
                   </a:txBody>
                   <a:tcPr marL="109728" marR="109728" marT="54864" marB="54864" anchor="ctr">
@@ -4099,12 +4114,87 @@
                       <a:r>
                         <a:rPr lang="en-US" sz="3200" b="1" dirty="0">
                           <a:solidFill>
-                            <a:schemeClr val="tx2"/>
+                            <a:schemeClr val="tx1"/>
                           </a:solidFill>
+                          <a:latin typeface="Courier New" pitchFamily="34" charset="0"/>
+                          <a:ea typeface="Courier New" pitchFamily="34" charset="-122"/>
+                          <a:cs typeface="Courier New" pitchFamily="34" charset="-120"/>
                         </a:rPr>
-                        <a:t>row 2</a:t>
+                        <a:t>explanation</a:t>
                       </a:r>
-                      <a:endParaRPr lang="en-US" sz="3200" dirty="0"/>
+                      <a:endParaRPr lang="en-US" sz="3200" dirty="0">
+                        <a:latin typeface="Courier New" charset="0"/>
+                        <a:ea typeface="Courier New" charset="0"/>
+                        <a:cs typeface="Courier New" charset="0"/>
+                      </a:endParaRPr>
+                    </a:p>
+                  </a:txBody>
+                  <a:tcPr marL="109728" marR="109728" marT="54864" marB="54864" anchor="ctr">
+                    <a:lnL w="12700" cap="flat" cmpd="sng" algn="ctr">
+                      <a:solidFill>
+                        <a:srgbClr val="DDE3E0"/>
+                      </a:solidFill>
+                      <a:prstDash val="solid"/>
+                      <a:round/>
+                      <a:headEnd type="none" w="med" len="med"/>
+                      <a:tailEnd type="none" w="med" len="med"/>
+                    </a:lnL>
+                    <a:lnR w="12700" cap="flat" cmpd="sng" algn="ctr">
+                      <a:solidFill>
+                        <a:srgbClr val="DDE3E0"/>
+                      </a:solidFill>
+                      <a:prstDash val="solid"/>
+                      <a:round/>
+                      <a:headEnd type="none" w="med" len="med"/>
+                      <a:tailEnd type="none" w="med" len="med"/>
+                    </a:lnR>
+                    <a:lnT w="12700" cap="flat" cmpd="sng" algn="ctr">
+                      <a:solidFill>
+                        <a:srgbClr val="DDE3E0"/>
+                      </a:solidFill>
+                      <a:prstDash val="solid"/>
+                      <a:round/>
+                      <a:headEnd type="none" w="med" len="med"/>
+                      <a:tailEnd type="none" w="med" len="med"/>
+                    </a:lnT>
+                    <a:lnB w="12700" cap="flat" cmpd="sng" algn="ctr">
+                      <a:solidFill>
+                        <a:srgbClr val="DDE3E0"/>
+                      </a:solidFill>
+                      <a:prstDash val="solid"/>
+                      <a:round/>
+                      <a:headEnd type="none" w="med" len="med"/>
+                      <a:tailEnd type="none" w="med" len="med"/>
+                    </a:lnB>
+                    <a:solidFill>
+                      <a:schemeClr val="bg1"/>
+                    </a:solidFill>
+                  </a:tcPr>
+                </a:tc>
+                <a:tc>
+                  <a:txBody>
+                    <a:bodyPr/>
+                    <a:lstStyle/>
+                    <a:p>
+                      <a:pPr indent="0" marL="0">
+                        <a:buNone/>
+                      </a:pPr>
+                      <a:r>
+                        <a:rPr lang="en-US" sz="3200" b="1" dirty="0">
+                          <a:solidFill>
+                            <a:schemeClr val="tx1"/>
+                          </a:solidFill>
+                          <a:latin typeface="Courier New" pitchFamily="34" charset="0"/>
+                          <a:ea typeface="Courier New" pitchFamily="34" charset="-122"/>
+                          <a:cs typeface="Courier New" pitchFamily="34" charset="-120"/>
+                        </a:rPr>
+                        <a:t>model</a:t>
+                      </a:r>
+                      <a:endParaRPr lang="en-US" sz="3200" dirty="0">
+                        <a:latin typeface="Courier New" charset="0"/>
+                        <a:ea typeface="Courier New" charset="0"/>
+                        <a:cs typeface="Courier New" charset="0"/>
+                      </a:endParaRPr>
                     </a:p>
                   </a:txBody>
                   <a:tcPr marL="109728" marR="109728" marT="54864" marB="54864" anchor="ctr">
@@ -4164,209 +4254,10 @@
                           <a:solidFill>
                             <a:schemeClr val="tx1"/>
                           </a:solidFill>
-                          <a:latin typeface="Courier New" pitchFamily="34" charset="0"/>
-                          <a:ea typeface="Courier New" pitchFamily="34" charset="-122"/>
-                          <a:cs typeface="Courier New" pitchFamily="34" charset="-120"/>
-                        </a:rPr>
-                        <a:t>term</a:t>
-                      </a:r>
-                      <a:endParaRPr lang="en-US" sz="3200" dirty="0">
-                        <a:latin typeface="Courier New" charset="0"/>
-                        <a:ea typeface="Courier New" charset="0"/>
-                        <a:cs typeface="Courier New" charset="0"/>
-                      </a:endParaRPr>
-                    </a:p>
-                  </a:txBody>
-                  <a:tcPr marL="109728" marR="109728" marT="54864" marB="54864" anchor="ctr">
-                    <a:lnL w="12700" cap="flat" cmpd="sng" algn="ctr">
-                      <a:solidFill>
-                        <a:srgbClr val="DDE3E0"/>
-                      </a:solidFill>
-                      <a:prstDash val="solid"/>
-                      <a:round/>
-                      <a:headEnd type="none" w="med" len="med"/>
-                      <a:tailEnd type="none" w="med" len="med"/>
-                    </a:lnL>
-                    <a:lnR w="12700" cap="flat" cmpd="sng" algn="ctr">
-                      <a:solidFill>
-                        <a:srgbClr val="DDE3E0"/>
-                      </a:solidFill>
-                      <a:prstDash val="solid"/>
-                      <a:round/>
-                      <a:headEnd type="none" w="med" len="med"/>
-                      <a:tailEnd type="none" w="med" len="med"/>
-                    </a:lnR>
-                    <a:lnT w="12700" cap="flat" cmpd="sng" algn="ctr">
-                      <a:solidFill>
-                        <a:srgbClr val="DDE3E0"/>
-                      </a:solidFill>
-                      <a:prstDash val="solid"/>
-                      <a:round/>
-                      <a:headEnd type="none" w="med" len="med"/>
-                      <a:tailEnd type="none" w="med" len="med"/>
-                    </a:lnT>
-                    <a:lnB w="12700" cap="flat" cmpd="sng" algn="ctr">
-                      <a:solidFill>
-                        <a:srgbClr val="DDE3E0"/>
-                      </a:solidFill>
-                      <a:prstDash val="solid"/>
-                      <a:round/>
-                      <a:headEnd type="none" w="med" len="med"/>
-                      <a:tailEnd type="none" w="med" len="med"/>
-                    </a:lnB>
-                    <a:solidFill>
-                      <a:schemeClr val="bg1"/>
-                    </a:solidFill>
-                  </a:tcPr>
-                </a:tc>
-                <a:tc>
-                  <a:txBody>
-                    <a:bodyPr/>
-                    <a:lstStyle/>
-                    <a:p>
-                      <a:pPr indent="0" marL="0">
-                        <a:buNone/>
-                      </a:pPr>
-                      <a:r>
-                        <a:rPr lang="en-US" sz="3200" b="1" dirty="0">
-                          <a:solidFill>
-                            <a:schemeClr val="tx1"/>
-                          </a:solidFill>
                         </a:rPr>
                         <a:t>hyponatremia</a:t>
                       </a:r>
                       <a:endParaRPr lang="en-US" sz="3200" dirty="0"/>
-                    </a:p>
-                  </a:txBody>
-                  <a:tcPr marL="109728" marR="109728" marT="54864" marB="54864" anchor="ctr">
-                    <a:lnL w="12700" cap="flat" cmpd="sng" algn="ctr">
-                      <a:solidFill>
-                        <a:srgbClr val="DDE3E0"/>
-                      </a:solidFill>
-                      <a:prstDash val="solid"/>
-                      <a:round/>
-                      <a:headEnd type="none" w="med" len="med"/>
-                      <a:tailEnd type="none" w="med" len="med"/>
-                    </a:lnL>
-                    <a:lnR w="12700" cap="flat" cmpd="sng" algn="ctr">
-                      <a:solidFill>
-                        <a:srgbClr val="DDE3E0"/>
-                      </a:solidFill>
-                      <a:prstDash val="solid"/>
-                      <a:round/>
-                      <a:headEnd type="none" w="med" len="med"/>
-                      <a:tailEnd type="none" w="med" len="med"/>
-                    </a:lnR>
-                    <a:lnT w="12700" cap="flat" cmpd="sng" algn="ctr">
-                      <a:solidFill>
-                        <a:srgbClr val="DDE3E0"/>
-                      </a:solidFill>
-                      <a:prstDash val="solid"/>
-                      <a:round/>
-                      <a:headEnd type="none" w="med" len="med"/>
-                      <a:tailEnd type="none" w="med" len="med"/>
-                    </a:lnT>
-                    <a:lnB w="12700" cap="flat" cmpd="sng" algn="ctr">
-                      <a:solidFill>
-                        <a:srgbClr val="DDE3E0"/>
-                      </a:solidFill>
-                      <a:prstDash val="solid"/>
-                      <a:round/>
-                      <a:headEnd type="none" w="med" len="med"/>
-                      <a:tailEnd type="none" w="med" len="med"/>
-                    </a:lnB>
-                    <a:solidFill>
-                      <a:schemeClr val="bg1"/>
-                    </a:solidFill>
-                  </a:tcPr>
-                </a:tc>
-                <a:tc>
-                  <a:txBody>
-                    <a:bodyPr/>
-                    <a:lstStyle/>
-                    <a:p>
-                      <a:pPr indent="0" marL="0">
-                        <a:buNone/>
-                      </a:pPr>
-                      <a:r>
-                        <a:rPr lang="en-US" sz="3200" b="1" dirty="0">
-                          <a:solidFill>
-                            <a:schemeClr val="tx1"/>
-                          </a:solidFill>
-                        </a:rPr>
-                        <a:t>potassium</a:t>
-                      </a:r>
-                      <a:endParaRPr lang="en-US" sz="3200" dirty="0"/>
-                    </a:p>
-                  </a:txBody>
-                  <a:tcPr marL="109728" marR="109728" marT="54864" marB="54864" anchor="ctr">
-                    <a:lnL w="12700" cap="flat" cmpd="sng" algn="ctr">
-                      <a:solidFill>
-                        <a:srgbClr val="DDE3E0"/>
-                      </a:solidFill>
-                      <a:prstDash val="solid"/>
-                      <a:round/>
-                      <a:headEnd type="none" w="med" len="med"/>
-                      <a:tailEnd type="none" w="med" len="med"/>
-                    </a:lnL>
-                    <a:lnR w="12700" cap="flat" cmpd="sng" algn="ctr">
-                      <a:solidFill>
-                        <a:srgbClr val="DDE3E0"/>
-                      </a:solidFill>
-                      <a:prstDash val="solid"/>
-                      <a:round/>
-                      <a:headEnd type="none" w="med" len="med"/>
-                      <a:tailEnd type="none" w="med" len="med"/>
-                    </a:lnR>
-                    <a:lnT w="12700" cap="flat" cmpd="sng" algn="ctr">
-                      <a:solidFill>
-                        <a:srgbClr val="DDE3E0"/>
-                      </a:solidFill>
-                      <a:prstDash val="solid"/>
-                      <a:round/>
-                      <a:headEnd type="none" w="med" len="med"/>
-                      <a:tailEnd type="none" w="med" len="med"/>
-                    </a:lnT>
-                    <a:lnB w="12700" cap="flat" cmpd="sng" algn="ctr">
-                      <a:solidFill>
-                        <a:srgbClr val="DDE3E0"/>
-                      </a:solidFill>
-                      <a:prstDash val="solid"/>
-                      <a:round/>
-                      <a:headEnd type="none" w="med" len="med"/>
-                      <a:tailEnd type="none" w="med" len="med"/>
-                    </a:lnB>
-                    <a:solidFill>
-                      <a:schemeClr val="bg1"/>
-                    </a:solidFill>
-                  </a:tcPr>
-                </a:tc>
-              </a:tr>
-              <a:tr h="0">
-                <a:tc>
-                  <a:txBody>
-                    <a:bodyPr/>
-                    <a:lstStyle/>
-                    <a:p>
-                      <a:pPr indent="0" marL="0">
-                        <a:buNone/>
-                      </a:pPr>
-                      <a:r>
-                        <a:rPr lang="en-US" sz="3200" dirty="0">
-                          <a:solidFill>
-                            <a:schemeClr val="tx1"/>
-                          </a:solidFill>
-                          <a:latin typeface="Courier New" pitchFamily="34" charset="0"/>
-                          <a:ea typeface="Courier New" pitchFamily="34" charset="-122"/>
-                          <a:cs typeface="Courier New" pitchFamily="34" charset="-120"/>
-                        </a:rPr>
-                        <a:t>search_count</a:t>
-                      </a:r>
-                      <a:endParaRPr lang="en-US" sz="3200" dirty="0">
-                        <a:latin typeface="Courier New" charset="0"/>
-                        <a:ea typeface="Courier New" charset="0"/>
-                        <a:cs typeface="Courier New" charset="0"/>
-                      </a:endParaRPr>
                     </a:p>
                   </a:txBody>
                   <a:tcPr marL="109728" marR="109728" marT="54864" marB="54864" anchor="ctr">
@@ -4428,137 +4319,6 @@
                         <a:t>3 (example)</a:t>
                       </a:r>
                       <a:endParaRPr lang="en-US" sz="3200" dirty="0"/>
-                    </a:p>
-                  </a:txBody>
-                  <a:tcPr marL="109728" marR="109728" marT="54864" marB="54864" anchor="ctr">
-                    <a:lnL w="12700" cap="flat" cmpd="sng" algn="ctr">
-                      <a:solidFill>
-                        <a:srgbClr val="DDE3E0"/>
-                      </a:solidFill>
-                      <a:prstDash val="solid"/>
-                      <a:round/>
-                      <a:headEnd type="none" w="med" len="med"/>
-                      <a:tailEnd type="none" w="med" len="med"/>
-                    </a:lnL>
-                    <a:lnR w="12700" cap="flat" cmpd="sng" algn="ctr">
-                      <a:solidFill>
-                        <a:srgbClr val="DDE3E0"/>
-                      </a:solidFill>
-                      <a:prstDash val="solid"/>
-                      <a:round/>
-                      <a:headEnd type="none" w="med" len="med"/>
-                      <a:tailEnd type="none" w="med" len="med"/>
-                    </a:lnR>
-                    <a:lnT w="12700" cap="flat" cmpd="sng" algn="ctr">
-                      <a:solidFill>
-                        <a:srgbClr val="DDE3E0"/>
-                      </a:solidFill>
-                      <a:prstDash val="solid"/>
-                      <a:round/>
-                      <a:headEnd type="none" w="med" len="med"/>
-                      <a:tailEnd type="none" w="med" len="med"/>
-                    </a:lnT>
-                    <a:lnB w="12700" cap="flat" cmpd="sng" algn="ctr">
-                      <a:solidFill>
-                        <a:srgbClr val="DDE3E0"/>
-                      </a:solidFill>
-                      <a:prstDash val="solid"/>
-                      <a:round/>
-                      <a:headEnd type="none" w="med" len="med"/>
-                      <a:tailEnd type="none" w="med" len="med"/>
-                    </a:lnB>
-                    <a:solidFill>
-                      <a:schemeClr val="bg1"/>
-                    </a:solidFill>
-                  </a:tcPr>
-                </a:tc>
-                <a:tc>
-                  <a:txBody>
-                    <a:bodyPr/>
-                    <a:lstStyle/>
-                    <a:p>
-                      <a:pPr indent="0" marL="0">
-                        <a:buNone/>
-                      </a:pPr>
-                      <a:r>
-                        <a:rPr lang="en-US" sz="3200" dirty="0">
-                          <a:solidFill>
-                            <a:schemeClr val="tx1"/>
-                          </a:solidFill>
-                        </a:rPr>
-                        <a:t>1 (example)</a:t>
-                      </a:r>
-                      <a:endParaRPr lang="en-US" sz="3200" dirty="0"/>
-                    </a:p>
-                  </a:txBody>
-                  <a:tcPr marL="109728" marR="109728" marT="54864" marB="54864" anchor="ctr">
-                    <a:lnL w="12700" cap="flat" cmpd="sng" algn="ctr">
-                      <a:solidFill>
-                        <a:srgbClr val="DDE3E0"/>
-                      </a:solidFill>
-                      <a:prstDash val="solid"/>
-                      <a:round/>
-                      <a:headEnd type="none" w="med" len="med"/>
-                      <a:tailEnd type="none" w="med" len="med"/>
-                    </a:lnL>
-                    <a:lnR w="12700" cap="flat" cmpd="sng" algn="ctr">
-                      <a:solidFill>
-                        <a:srgbClr val="DDE3E0"/>
-                      </a:solidFill>
-                      <a:prstDash val="solid"/>
-                      <a:round/>
-                      <a:headEnd type="none" w="med" len="med"/>
-                      <a:tailEnd type="none" w="med" len="med"/>
-                    </a:lnR>
-                    <a:lnT w="12700" cap="flat" cmpd="sng" algn="ctr">
-                      <a:solidFill>
-                        <a:srgbClr val="DDE3E0"/>
-                      </a:solidFill>
-                      <a:prstDash val="solid"/>
-                      <a:round/>
-                      <a:headEnd type="none" w="med" len="med"/>
-                      <a:tailEnd type="none" w="med" len="med"/>
-                    </a:lnT>
-                    <a:lnB w="12700" cap="flat" cmpd="sng" algn="ctr">
-                      <a:solidFill>
-                        <a:srgbClr val="DDE3E0"/>
-                      </a:solidFill>
-                      <a:prstDash val="solid"/>
-                      <a:round/>
-                      <a:headEnd type="none" w="med" len="med"/>
-                      <a:tailEnd type="none" w="med" len="med"/>
-                    </a:lnB>
-                    <a:solidFill>
-                      <a:schemeClr val="bg1"/>
-                    </a:solidFill>
-                  </a:tcPr>
-                </a:tc>
-              </a:tr>
-              <a:tr h="0">
-                <a:tc>
-                  <a:txBody>
-                    <a:bodyPr/>
-                    <a:lstStyle/>
-                    <a:p>
-                      <a:pPr indent="0" marL="0">
-                        <a:buNone/>
-                      </a:pPr>
-                      <a:r>
-                        <a:rPr lang="en-US" sz="3200" dirty="0">
-                          <a:solidFill>
-                            <a:schemeClr val="tx1"/>
-                          </a:solidFill>
-                          <a:latin typeface="Courier New" pitchFamily="34" charset="0"/>
-                          <a:ea typeface="Courier New" pitchFamily="34" charset="-122"/>
-                          <a:cs typeface="Courier New" pitchFamily="34" charset="-120"/>
-                        </a:rPr>
-                        <a:t>explanation</a:t>
-                      </a:r>
-                      <a:endParaRPr lang="en-US" sz="3200" dirty="0">
-                        <a:latin typeface="Courier New" charset="0"/>
-                        <a:ea typeface="Courier New" charset="0"/>
-                        <a:cs typeface="Courier New" charset="0"/>
-                      </a:endParaRPr>
                     </a:p>
                   </a:txBody>
                   <a:tcPr marL="109728" marR="109728" marT="54864" marB="54864" anchor="ctr">
@@ -4631,7 +4391,192 @@
                             <a:schemeClr val="accent1"/>
                           </a:solidFill>
                         </a:rPr>
-                        <a:t>Reviewed by AI</a:t>
+                        <a:t>Reviewed</a:t>
+                      </a:r>
+                      <a:endParaRPr lang="en-US" sz="3200" dirty="0"/>
+                    </a:p>
+                  </a:txBody>
+                  <a:tcPr marL="109728" marR="109728" marT="54864" marB="54864" anchor="ctr">
+                    <a:lnL w="12700" cap="flat" cmpd="sng" algn="ctr">
+                      <a:solidFill>
+                        <a:srgbClr val="DDE3E0"/>
+                      </a:solidFill>
+                      <a:prstDash val="solid"/>
+                      <a:round/>
+                      <a:headEnd type="none" w="med" len="med"/>
+                      <a:tailEnd type="none" w="med" len="med"/>
+                    </a:lnL>
+                    <a:lnR w="12700" cap="flat" cmpd="sng" algn="ctr">
+                      <a:solidFill>
+                        <a:srgbClr val="DDE3E0"/>
+                      </a:solidFill>
+                      <a:prstDash val="solid"/>
+                      <a:round/>
+                      <a:headEnd type="none" w="med" len="med"/>
+                      <a:tailEnd type="none" w="med" len="med"/>
+                    </a:lnR>
+                    <a:lnT w="12700" cap="flat" cmpd="sng" algn="ctr">
+                      <a:solidFill>
+                        <a:srgbClr val="DDE3E0"/>
+                      </a:solidFill>
+                      <a:prstDash val="solid"/>
+                      <a:round/>
+                      <a:headEnd type="none" w="med" len="med"/>
+                      <a:tailEnd type="none" w="med" len="med"/>
+                    </a:lnT>
+                    <a:lnB w="12700" cap="flat" cmpd="sng" algn="ctr">
+                      <a:solidFill>
+                        <a:srgbClr val="DDE3E0"/>
+                      </a:solidFill>
+                      <a:prstDash val="solid"/>
+                      <a:round/>
+                      <a:headEnd type="none" w="med" len="med"/>
+                      <a:tailEnd type="none" w="med" len="med"/>
+                    </a:lnB>
+                    <a:solidFill>
+                      <a:schemeClr val="bg1"/>
+                    </a:solidFill>
+                  </a:tcPr>
+                </a:tc>
+                <a:tc>
+                  <a:txBody>
+                    <a:bodyPr/>
+                    <a:lstStyle/>
+                    <a:p>
+                      <a:pPr indent="0" marL="0">
+                        <a:buNone/>
+                      </a:pPr>
+                      <a:r>
+                        <a:rPr lang="en-US" sz="3200" dirty="0">
+                          <a:solidFill>
+                            <a:schemeClr val="tx1"/>
+                          </a:solidFill>
+                        </a:rPr>
+                        <a:t>Llama 3.3 70B</a:t>
+                      </a:r>
+                      <a:endParaRPr lang="en-US" sz="3200" dirty="0"/>
+                    </a:p>
+                  </a:txBody>
+                  <a:tcPr marL="109728" marR="109728" marT="54864" marB="54864" anchor="ctr">
+                    <a:lnL w="12700" cap="flat" cmpd="sng" algn="ctr">
+                      <a:solidFill>
+                        <a:srgbClr val="DDE3E0"/>
+                      </a:solidFill>
+                      <a:prstDash val="solid"/>
+                      <a:round/>
+                      <a:headEnd type="none" w="med" len="med"/>
+                      <a:tailEnd type="none" w="med" len="med"/>
+                    </a:lnL>
+                    <a:lnR w="12700" cap="flat" cmpd="sng" algn="ctr">
+                      <a:solidFill>
+                        <a:srgbClr val="DDE3E0"/>
+                      </a:solidFill>
+                      <a:prstDash val="solid"/>
+                      <a:round/>
+                      <a:headEnd type="none" w="med" len="med"/>
+                      <a:tailEnd type="none" w="med" len="med"/>
+                    </a:lnR>
+                    <a:lnT w="12700" cap="flat" cmpd="sng" algn="ctr">
+                      <a:solidFill>
+                        <a:srgbClr val="DDE3E0"/>
+                      </a:solidFill>
+                      <a:prstDash val="solid"/>
+                      <a:round/>
+                      <a:headEnd type="none" w="med" len="med"/>
+                      <a:tailEnd type="none" w="med" len="med"/>
+                    </a:lnT>
+                    <a:lnB w="12700" cap="flat" cmpd="sng" algn="ctr">
+                      <a:solidFill>
+                        <a:srgbClr val="DDE3E0"/>
+                      </a:solidFill>
+                      <a:prstDash val="solid"/>
+                      <a:round/>
+                      <a:headEnd type="none" w="med" len="med"/>
+                      <a:tailEnd type="none" w="med" len="med"/>
+                    </a:lnB>
+                    <a:solidFill>
+                      <a:schemeClr val="bg1"/>
+                    </a:solidFill>
+                  </a:tcPr>
+                </a:tc>
+              </a:tr>
+              <a:tr h="0">
+                <a:tc>
+                  <a:txBody>
+                    <a:bodyPr/>
+                    <a:lstStyle/>
+                    <a:p>
+                      <a:pPr indent="0" marL="0">
+                        <a:buNone/>
+                      </a:pPr>
+                      <a:r>
+                        <a:rPr lang="en-US" sz="3200" dirty="0">
+                          <a:solidFill>
+                            <a:schemeClr val="tx1"/>
+                          </a:solidFill>
+                        </a:rPr>
+                        <a:t>potassium</a:t>
+                      </a:r>
+                      <a:endParaRPr lang="en-US" sz="3200" dirty="0"/>
+                    </a:p>
+                  </a:txBody>
+                  <a:tcPr marL="109728" marR="109728" marT="54864" marB="54864" anchor="ctr">
+                    <a:lnL w="12700" cap="flat" cmpd="sng" algn="ctr">
+                      <a:solidFill>
+                        <a:srgbClr val="DDE3E0"/>
+                      </a:solidFill>
+                      <a:prstDash val="solid"/>
+                      <a:round/>
+                      <a:headEnd type="none" w="med" len="med"/>
+                      <a:tailEnd type="none" w="med" len="med"/>
+                    </a:lnL>
+                    <a:lnR w="12700" cap="flat" cmpd="sng" algn="ctr">
+                      <a:solidFill>
+                        <a:srgbClr val="DDE3E0"/>
+                      </a:solidFill>
+                      <a:prstDash val="solid"/>
+                      <a:round/>
+                      <a:headEnd type="none" w="med" len="med"/>
+                      <a:tailEnd type="none" w="med" len="med"/>
+                    </a:lnR>
+                    <a:lnT w="12700" cap="flat" cmpd="sng" algn="ctr">
+                      <a:solidFill>
+                        <a:srgbClr val="DDE3E0"/>
+                      </a:solidFill>
+                      <a:prstDash val="solid"/>
+                      <a:round/>
+                      <a:headEnd type="none" w="med" len="med"/>
+                      <a:tailEnd type="none" w="med" len="med"/>
+                    </a:lnT>
+                    <a:lnB w="12700" cap="flat" cmpd="sng" algn="ctr">
+                      <a:solidFill>
+                        <a:srgbClr val="DDE3E0"/>
+                      </a:solidFill>
+                      <a:prstDash val="solid"/>
+                      <a:round/>
+                      <a:headEnd type="none" w="med" len="med"/>
+                      <a:tailEnd type="none" w="med" len="med"/>
+                    </a:lnB>
+                    <a:solidFill>
+                      <a:schemeClr val="bg1"/>
+                    </a:solidFill>
+                  </a:tcPr>
+                </a:tc>
+                <a:tc>
+                  <a:txBody>
+                    <a:bodyPr/>
+                    <a:lstStyle/>
+                    <a:p>
+                      <a:pPr indent="0" marL="0">
+                        <a:buNone/>
+                      </a:pPr>
+                      <a:r>
+                        <a:rPr lang="en-US" sz="3200" dirty="0">
+                          <a:solidFill>
+                            <a:schemeClr val="tx1"/>
+                          </a:solidFill>
+                        </a:rPr>
+                        <a:t>1 (example)</a:t>
                       </a:r>
                       <a:endParaRPr lang="en-US" sz="3200" dirty="0"/>
                     </a:p>
@@ -4739,137 +4684,6 @@
                     </a:solidFill>
                   </a:tcPr>
                 </a:tc>
-              </a:tr>
-              <a:tr h="0">
-                <a:tc>
-                  <a:txBody>
-                    <a:bodyPr/>
-                    <a:lstStyle/>
-                    <a:p>
-                      <a:pPr indent="0" marL="0">
-                        <a:buNone/>
-                      </a:pPr>
-                      <a:r>
-                        <a:rPr lang="en-US" sz="3200" dirty="0">
-                          <a:solidFill>
-                            <a:schemeClr val="tx1"/>
-                          </a:solidFill>
-                          <a:latin typeface="Courier New" pitchFamily="34" charset="0"/>
-                          <a:ea typeface="Courier New" pitchFamily="34" charset="-122"/>
-                          <a:cs typeface="Courier New" pitchFamily="34" charset="-120"/>
-                        </a:rPr>
-                        <a:t>model</a:t>
-                      </a:r>
-                      <a:endParaRPr lang="en-US" sz="3200" dirty="0">
-                        <a:latin typeface="Courier New" charset="0"/>
-                        <a:ea typeface="Courier New" charset="0"/>
-                        <a:cs typeface="Courier New" charset="0"/>
-                      </a:endParaRPr>
-                    </a:p>
-                  </a:txBody>
-                  <a:tcPr marL="109728" marR="109728" marT="54864" marB="54864" anchor="ctr">
-                    <a:lnL w="12700" cap="flat" cmpd="sng" algn="ctr">
-                      <a:solidFill>
-                        <a:srgbClr val="DDE3E0"/>
-                      </a:solidFill>
-                      <a:prstDash val="solid"/>
-                      <a:round/>
-                      <a:headEnd type="none" w="med" len="med"/>
-                      <a:tailEnd type="none" w="med" len="med"/>
-                    </a:lnL>
-                    <a:lnR w="12700" cap="flat" cmpd="sng" algn="ctr">
-                      <a:solidFill>
-                        <a:srgbClr val="DDE3E0"/>
-                      </a:solidFill>
-                      <a:prstDash val="solid"/>
-                      <a:round/>
-                      <a:headEnd type="none" w="med" len="med"/>
-                      <a:tailEnd type="none" w="med" len="med"/>
-                    </a:lnR>
-                    <a:lnT w="12700" cap="flat" cmpd="sng" algn="ctr">
-                      <a:solidFill>
-                        <a:srgbClr val="DDE3E0"/>
-                      </a:solidFill>
-                      <a:prstDash val="solid"/>
-                      <a:round/>
-                      <a:headEnd type="none" w="med" len="med"/>
-                      <a:tailEnd type="none" w="med" len="med"/>
-                    </a:lnT>
-                    <a:lnB w="12700" cap="flat" cmpd="sng" algn="ctr">
-                      <a:solidFill>
-                        <a:srgbClr val="DDE3E0"/>
-                      </a:solidFill>
-                      <a:prstDash val="solid"/>
-                      <a:round/>
-                      <a:headEnd type="none" w="med" len="med"/>
-                      <a:tailEnd type="none" w="med" len="med"/>
-                    </a:lnB>
-                    <a:solidFill>
-                      <a:schemeClr val="bg1"/>
-                    </a:solidFill>
-                  </a:tcPr>
-                </a:tc>
-                <a:tc>
-                  <a:txBody>
-                    <a:bodyPr/>
-                    <a:lstStyle/>
-                    <a:p>
-                      <a:pPr indent="0" marL="0">
-                        <a:buNone/>
-                      </a:pPr>
-                      <a:r>
-                        <a:rPr lang="en-US" sz="3200" dirty="0">
-                          <a:solidFill>
-                            <a:schemeClr val="tx1"/>
-                          </a:solidFill>
-                        </a:rPr>
-                        <a:t>Llama 3.3 70B</a:t>
-                      </a:r>
-                      <a:endParaRPr lang="en-US" sz="3200" dirty="0"/>
-                    </a:p>
-                  </a:txBody>
-                  <a:tcPr marL="109728" marR="109728" marT="54864" marB="54864" anchor="ctr">
-                    <a:lnL w="12700" cap="flat" cmpd="sng" algn="ctr">
-                      <a:solidFill>
-                        <a:srgbClr val="DDE3E0"/>
-                      </a:solidFill>
-                      <a:prstDash val="solid"/>
-                      <a:round/>
-                      <a:headEnd type="none" w="med" len="med"/>
-                      <a:tailEnd type="none" w="med" len="med"/>
-                    </a:lnL>
-                    <a:lnR w="12700" cap="flat" cmpd="sng" algn="ctr">
-                      <a:solidFill>
-                        <a:srgbClr val="DDE3E0"/>
-                      </a:solidFill>
-                      <a:prstDash val="solid"/>
-                      <a:round/>
-                      <a:headEnd type="none" w="med" len="med"/>
-                      <a:tailEnd type="none" w="med" len="med"/>
-                    </a:lnR>
-                    <a:lnT w="12700" cap="flat" cmpd="sng" algn="ctr">
-                      <a:solidFill>
-                        <a:srgbClr val="DDE3E0"/>
-                      </a:solidFill>
-                      <a:prstDash val="solid"/>
-                      <a:round/>
-                      <a:headEnd type="none" w="med" len="med"/>
-                      <a:tailEnd type="none" w="med" len="med"/>
-                    </a:lnT>
-                    <a:lnB w="12700" cap="flat" cmpd="sng" algn="ctr">
-                      <a:solidFill>
-                        <a:srgbClr val="DDE3E0"/>
-                      </a:solidFill>
-                      <a:prstDash val="solid"/>
-                      <a:round/>
-                      <a:headEnd type="none" w="med" len="med"/>
-                      <a:tailEnd type="none" w="med" len="med"/>
-                    </a:lnB>
-                    <a:solidFill>
-                      <a:schemeClr val="bg1"/>
-                    </a:solidFill>
-                  </a:tcPr>
-                </a:tc>
                 <a:tc>
                   <a:txBody>
                     <a:bodyPr/>
@@ -4944,7 +4758,7 @@
         </p:nvSpPr>
         <p:spPr>
           <a:xfrm>
-            <a:off x="548640" y="5943600"/>
+            <a:off x="548640" y="5440680"/>
             <a:ext cx="11094415" cy="502920"/>
           </a:xfrm>
           <a:prstGeom prst="rect">

</xml_diff>

<commit_message>
Final check on the reviewer's corrections before they're saved
When the reviewer rewrites an answer, nobody else has checked that text,
so the code checks now run once more on the correction. If it still
sounds like a cause or advice, reads above grade 7 (one grade of slack
for the medical term itself), repeats the term as a word part, has
personal details, or has no care-team questions, the visitor still sees
it, badged "Issues flagged: not saved", and the glossary doesn't keep
it, so small problems can't become permanent. Approved drafts aren't
re-checked: the reviewer already judged the code's findings for them.
PROMPT_VERSION 11 so earlier saved corrections are redone under the new
rule. Deck slide 4 and the README describe the final check.

Co-Authored-By: Claude Opus 5.5 <noreply@anthropic.com>
Claude-Session: https://claude.ai/code/session_01Sc6RkpjCNnA9gTjSdaAsnK
</commit_message>
<xml_diff>
--- a/presentation/plainly-deck.pptx
+++ b/presentation/plainly-deck.pptx
@@ -783,9 +783,9 @@
               <a:t>4. The writer AI (Llama 3.3 70B on Cloudflare Workers AI) drafts the explanation at temperature 0, following worked examples.
 5. Code checks what a computer can: reading grade, phrases that sound like causes or advice, personal details.
 6. The reviewer AI (gpt-oss-120b) checks the draft against the five rules — no causes or advice, grade 6 or below, correct word roots, no personal details, care-team questions — and approves it or returns a corrected version.
-7. Only approved or corrected answers are saved, so the next search for the term is instant.
+7. Final check: if the reviewer rewrote the answer, the code checks run again on its version, because nobody else has checked that text. Only answers that pass are saved, so no small problem gets locked into the glossary. The next search for the term is then instant.
 8. The visitor sees the answer with a badge: “Checked by reviewer AI” or “Corrected by reviewer AI.”
-If the reviewer is unavailable, the answer is still shown, marked “Not yet reviewed,” and isn’t saved.
+If the final check flags something, or the reviewer is unavailable, the answer is still shown, with a badge saying so, but it isn’t saved; the next search tries again.
 Source: project code, src/pipeline.js and src/models.js; README “How it works.”</a:t>
             </a:r>
             <a:endParaRPr lang="en-US" dirty="0"/>
@@ -2704,7 +2704,21 @@
                   <a:schemeClr val="tx1"/>
                 </a:solidFill>
               </a:rPr>
-              <a:t>Saved to the glossary</a:t>
+              <a:t>Final check,</a:t>
+            </a:r>
+            <a:endParaRPr lang="en-US" sz="3200" dirty="0"/>
+          </a:p>
+          <a:p>
+            <a:pPr algn="ctr" indent="0" marL="0">
+              <a:buNone/>
+            </a:pPr>
+            <a:r>
+              <a:rPr lang="en-US" sz="3200" dirty="0">
+                <a:solidFill>
+                  <a:schemeClr val="tx1"/>
+                </a:solidFill>
+              </a:rPr>
+              <a:t>then saved</a:t>
             </a:r>
             <a:endParaRPr lang="en-US" sz="3200" dirty="0"/>
           </a:p>

</xml_diff>

<commit_message>
Deck: add slide 7 on the private review_log table (8 slides)
Example rows laid out like the real table (term, outcome, failed_rules,
notes); speaker notes cover all 10 columns, why it's private, and the
privacy guard. The demo is now slide 8.

Co-Authored-By: Claude Opus 5.5 <noreply@anthropic.com>
Claude-Session: https://claude.ai/code/session_01Sc6RkpjCNnA9gTjSdaAsnK
</commit_message>
<xml_diff>
--- a/presentation/plainly-deck.pptx
+++ b/presentation/plainly-deck.pptx
@@ -12,9 +12,10 @@
     <p:sldId id="260" r:id="rId6"/>
     <p:sldId id="261" r:id="rId7"/>
     <p:sldId id="262" r:id="rId8"/>
+    <p:sldId id="263" r:id="rId9"/>
   </p:sldIdLst>
   <p:notesMasterIdLst>
-    <p:notesMasterId r:id="rId9"/>
+    <p:notesMasterId r:id="rId10"/>
   </p:notesMasterIdLst>
   <p:sldSz cx="12192000" cy="6858000"/>
   <p:notesSz cx="6858000" cy="12192000"/>
@@ -1059,6 +1060,99 @@
           <a:p>
             <a:r>
               <a:rPr lang="en-US" dirty="0"/>
+              <a:t>Every new answer’s review is recorded in a second Supabase table, review_log, so admins can judge how well the AI models are doing. It has 10 columns: id, created_at, term, outcome (approved, corrected, failed, skipped or not_understood), failed_rules (which of the five rules the draft broke), notes (the reviewer’s explanation), writer_model, reviewer_model, prompt_version and seconds.
+How it differs from the glossary: the glossary is public, with one row per term; the review log is private, with one row per review. Row-level security gives the public no access at all; only the site’s server can write to it, and admins read it in Supabase’s Table Editor.
+Why it’s private: a failed draft can contain harmful text — for example, a prediction about someone’s health. Visitors never see failed drafts or the reasons they failed; they get a gentle “couldn’t double-check” note instead. Admins see the details here.
+Privacy: like the glossary, it never stores who searched or what they typed. If the input looked personal, only the outcome and rule numbers are kept, never the reviewer’s notes.
+The rows shown are examples of the format, with the notes shortened, not live data.
+Source: project code, supabase/migrations/0002_review_log.sql and src/reviewlog.js.</a:t>
+            </a:r>
+            <a:endParaRPr lang="en-US" dirty="0"/>
+          </a:p>
+        </p:txBody>
+      </p:sp>
+      <p:sp>
+        <p:nvSpPr>
+          <p:cNvPr id="4" name="Slide Number Placeholder 3"/>
+          <p:cNvSpPr>
+            <a:spLocks noGrp="1"/>
+          </p:cNvSpPr>
+          <p:nvPr>
+            <p:ph type="sldNum" sz="quarter" idx="10"/>
+          </p:nvPr>
+        </p:nvSpPr>
+        <p:spPr/>
+        <p:txBody>
+          <a:bodyPr/>
+          <a:lstStyle/>
+          <a:p>
+            <a:fld id="{F7021451-1387-4CA6-816F-3879F97B5CBC}" type="slidenum">
+              <a:rPr lang="en-US"/>
+              <a:t>7</a:t>
+            </a:fld>
+            <a:endParaRPr lang="en-US"/>
+          </a:p>
+        </p:txBody>
+      </p:sp>
+    </p:spTree>
+    <p:extLst>
+      <p:ext uri="{BB962C8B-B14F-4D97-AF65-F5344CB8AC3E}">
+        <p14:creationId xmlns:p14="http://schemas.microsoft.com/office/powerpoint/2010/main" val="1024086991"/>
+      </p:ext>
+    </p:extLst>
+  </p:cSld>
+  <p:clrMapOvr>
+    <a:masterClrMapping/>
+  </p:clrMapOvr>
+</p:notes>
+</file>
+
+<file path=ppt/notesSlides/notesSlide8.xml><?xml version="1.0" encoding="utf-8"?>
+<p:notes xmlns:a="http://schemas.openxmlformats.org/drawingml/2006/main" xmlns:r="http://schemas.openxmlformats.org/officeDocument/2006/relationships" xmlns:p="http://schemas.openxmlformats.org/presentationml/2006/main">
+  <p:cSld>
+    <p:spTree>
+      <p:nvGrpSpPr>
+        <p:cNvPr id="1" name=""/>
+        <p:cNvGrpSpPr/>
+        <p:nvPr/>
+      </p:nvGrpSpPr>
+      <p:grpSpPr>
+        <a:xfrm>
+          <a:off x="0" y="0"/>
+          <a:ext cx="0" cy="0"/>
+          <a:chOff x="0" y="0"/>
+          <a:chExt cx="0" cy="0"/>
+        </a:xfrm>
+      </p:grpSpPr>
+      <p:sp>
+        <p:nvSpPr>
+          <p:cNvPr id="2" name="Slide Image Placeholder 1"/>
+          <p:cNvSpPr>
+            <a:spLocks noGrp="1" noRot="1" noChangeAspect="1"/>
+          </p:cNvSpPr>
+          <p:nvPr>
+            <p:ph type="sldImg"/>
+          </p:nvPr>
+        </p:nvSpPr>
+        <p:spPr/>
+      </p:sp>
+      <p:sp>
+        <p:nvSpPr>
+          <p:cNvPr id="3" name="Notes Placeholder 2"/>
+          <p:cNvSpPr>
+            <a:spLocks noGrp="1"/>
+          </p:cNvSpPr>
+          <p:nvPr>
+            <p:ph type="body" idx="1"/>
+          </p:nvPr>
+        </p:nvSpPr>
+        <p:spPr/>
+        <p:txBody>
+          <a:bodyPr/>
+          <a:lstStyle/>
+          <a:p>
+            <a:r>
+              <a:rPr lang="en-US" dirty="0"/>
               <a:t>Live: https://plainly-medical-explainer.kimtastico.workers.dev
 1. Search “hyponatremia”: the writer drafts, the reviewer checks, about 5 seconds. Point out the AI notice under the answer.
 2. Search it again: instant, “From the glossary,” word for word the same.
@@ -1089,7 +1183,7 @@
           <a:p>
             <a:fld id="{F7021451-1387-4CA6-816F-3879F97B5CBC}" type="slidenum">
               <a:rPr lang="en-US"/>
-              <a:t>7</a:t>
+              <a:t>8</a:t>
             </a:fld>
             <a:endParaRPr lang="en-US"/>
           </a:p>
@@ -4882,6 +4976,1210 @@
                   <a:schemeClr val="tx1"/>
                 </a:solidFill>
               </a:rPr>
+              <a:t>Admins see how every review went</a:t>
+            </a:r>
+            <a:endParaRPr lang="en-US" sz="4000" dirty="0"/>
+          </a:p>
+        </p:txBody>
+      </p:sp>
+      <p:sp>
+        <p:nvSpPr>
+          <p:cNvPr id="3" name="Table name"/>
+          <p:cNvSpPr txBox="1"/>
+          <p:nvPr/>
+        </p:nvSpPr>
+        <p:spPr>
+          <a:xfrm>
+            <a:off x="548640" y="1325880"/>
+            <a:ext cx="11094415" cy="502920"/>
+          </a:xfrm>
+          <a:prstGeom prst="rect">
+            <a:avLst/>
+          </a:prstGeom>
+          <a:noFill/>
+          <a:ln/>
+        </p:spPr>
+        <p:txBody>
+          <a:bodyPr wrap="square" lIns="0" tIns="0" rIns="0" bIns="0" rtlCol="0" anchor="ctr"/>
+          <a:lstStyle/>
+          <a:p>
+            <a:pPr indent="0" marL="0">
+              <a:buNone/>
+            </a:pPr>
+            <a:r>
+              <a:rPr lang="en-US" sz="3200" dirty="0">
+                <a:solidFill>
+                  <a:schemeClr val="tx1"/>
+                </a:solidFill>
+              </a:rPr>
+              <a:t>Private Supabase table: </a:t>
+            </a:r>
+            <a:pPr indent="0" marL="0">
+              <a:buNone/>
+            </a:pPr>
+            <a:r>
+              <a:rPr lang="en-US" sz="3200" dirty="0">
+                <a:solidFill>
+                  <a:schemeClr val="tx1"/>
+                </a:solidFill>
+                <a:latin typeface="Courier New" pitchFamily="34" charset="0"/>
+                <a:ea typeface="Courier New" pitchFamily="34" charset="-122"/>
+                <a:cs typeface="Courier New" pitchFamily="34" charset="-120"/>
+              </a:rPr>
+              <a:t>review_log</a:t>
+            </a:r>
+            <a:pPr indent="0" marL="0">
+              <a:buNone/>
+            </a:pPr>
+            <a:r>
+              <a:rPr lang="en-US" sz="3200" dirty="0">
+                <a:solidFill>
+                  <a:schemeClr val="tx1"/>
+                </a:solidFill>
+              </a:rPr>
+              <a:t> (example rows)</a:t>
+            </a:r>
+            <a:endParaRPr lang="en-US" sz="3200" dirty="0"/>
+          </a:p>
+        </p:txBody>
+      </p:sp>
+      <p:graphicFrame>
+        <p:nvGraphicFramePr>
+          <p:cNvPr id="8" name="Example review rows"/>
+          <p:cNvGraphicFramePr>
+            <a:graphicFrameLocks noGrp="1"/>
+          </p:cNvGraphicFramePr>
+          <p:nvPr>
+            <p:extLst>
+              <p:ext uri="{D42A27DB-BD31-4B8C-83A1-F6EECF244321}">
+                <p14:modId xmlns:p14="http://schemas.microsoft.com/office/powerpoint/2010/main" val="1579011935"/>
+              </p:ext>
+            </p:extLst>
+          </p:nvPr>
+        </p:nvGraphicFramePr>
+        <p:xfrm>
+          <a:off x="548640" y="1965960"/>
+          <a:ext cx="11094415" cy="914400"/>
+        </p:xfrm>
+        <a:graphic>
+          <a:graphicData uri="http://schemas.openxmlformats.org/drawingml/2006/table">
+            <a:tbl>
+              <a:tblPr/>
+              <a:tblGrid>
+                <a:gridCol w="2971800"/>
+                <a:gridCol w="2331720"/>
+                <a:gridCol w="3154680"/>
+                <a:gridCol w="2633472"/>
+              </a:tblGrid>
+              <a:tr h="0">
+                <a:tc>
+                  <a:txBody>
+                    <a:bodyPr/>
+                    <a:lstStyle/>
+                    <a:p>
+                      <a:pPr indent="0" marL="0">
+                        <a:buNone/>
+                      </a:pPr>
+                      <a:r>
+                        <a:rPr lang="en-US" sz="3200" b="1" dirty="0">
+                          <a:solidFill>
+                            <a:schemeClr val="tx1"/>
+                          </a:solidFill>
+                          <a:latin typeface="Courier New" pitchFamily="34" charset="0"/>
+                          <a:ea typeface="Courier New" pitchFamily="34" charset="-122"/>
+                          <a:cs typeface="Courier New" pitchFamily="34" charset="-120"/>
+                        </a:rPr>
+                        <a:t>term</a:t>
+                      </a:r>
+                      <a:endParaRPr lang="en-US" sz="3200" dirty="0">
+                        <a:latin typeface="Courier New" charset="0"/>
+                        <a:ea typeface="Courier New" charset="0"/>
+                        <a:cs typeface="Courier New" charset="0"/>
+                      </a:endParaRPr>
+                    </a:p>
+                  </a:txBody>
+                  <a:tcPr marL="109728" marR="109728" marT="54864" marB="54864" anchor="ctr">
+                    <a:lnL w="12700" cap="flat" cmpd="sng" algn="ctr">
+                      <a:solidFill>
+                        <a:srgbClr val="DDE3E0"/>
+                      </a:solidFill>
+                      <a:prstDash val="solid"/>
+                      <a:round/>
+                      <a:headEnd type="none" w="med" len="med"/>
+                      <a:tailEnd type="none" w="med" len="med"/>
+                    </a:lnL>
+                    <a:lnR w="12700" cap="flat" cmpd="sng" algn="ctr">
+                      <a:solidFill>
+                        <a:srgbClr val="DDE3E0"/>
+                      </a:solidFill>
+                      <a:prstDash val="solid"/>
+                      <a:round/>
+                      <a:headEnd type="none" w="med" len="med"/>
+                      <a:tailEnd type="none" w="med" len="med"/>
+                    </a:lnR>
+                    <a:lnT w="12700" cap="flat" cmpd="sng" algn="ctr">
+                      <a:solidFill>
+                        <a:srgbClr val="DDE3E0"/>
+                      </a:solidFill>
+                      <a:prstDash val="solid"/>
+                      <a:round/>
+                      <a:headEnd type="none" w="med" len="med"/>
+                      <a:tailEnd type="none" w="med" len="med"/>
+                    </a:lnT>
+                    <a:lnB w="12700" cap="flat" cmpd="sng" algn="ctr">
+                      <a:solidFill>
+                        <a:srgbClr val="DDE3E0"/>
+                      </a:solidFill>
+                      <a:prstDash val="solid"/>
+                      <a:round/>
+                      <a:headEnd type="none" w="med" len="med"/>
+                      <a:tailEnd type="none" w="med" len="med"/>
+                    </a:lnB>
+                    <a:solidFill>
+                      <a:schemeClr val="bg1"/>
+                    </a:solidFill>
+                  </a:tcPr>
+                </a:tc>
+                <a:tc>
+                  <a:txBody>
+                    <a:bodyPr/>
+                    <a:lstStyle/>
+                    <a:p>
+                      <a:pPr indent="0" marL="0">
+                        <a:buNone/>
+                      </a:pPr>
+                      <a:r>
+                        <a:rPr lang="en-US" sz="3200" b="1" dirty="0">
+                          <a:solidFill>
+                            <a:schemeClr val="tx1"/>
+                          </a:solidFill>
+                          <a:latin typeface="Courier New" pitchFamily="34" charset="0"/>
+                          <a:ea typeface="Courier New" pitchFamily="34" charset="-122"/>
+                          <a:cs typeface="Courier New" pitchFamily="34" charset="-120"/>
+                        </a:rPr>
+                        <a:t>outcome</a:t>
+                      </a:r>
+                      <a:endParaRPr lang="en-US" sz="3200" dirty="0">
+                        <a:latin typeface="Courier New" charset="0"/>
+                        <a:ea typeface="Courier New" charset="0"/>
+                        <a:cs typeface="Courier New" charset="0"/>
+                      </a:endParaRPr>
+                    </a:p>
+                  </a:txBody>
+                  <a:tcPr marL="109728" marR="109728" marT="54864" marB="54864" anchor="ctr">
+                    <a:lnL w="12700" cap="flat" cmpd="sng" algn="ctr">
+                      <a:solidFill>
+                        <a:srgbClr val="DDE3E0"/>
+                      </a:solidFill>
+                      <a:prstDash val="solid"/>
+                      <a:round/>
+                      <a:headEnd type="none" w="med" len="med"/>
+                      <a:tailEnd type="none" w="med" len="med"/>
+                    </a:lnL>
+                    <a:lnR w="12700" cap="flat" cmpd="sng" algn="ctr">
+                      <a:solidFill>
+                        <a:srgbClr val="DDE3E0"/>
+                      </a:solidFill>
+                      <a:prstDash val="solid"/>
+                      <a:round/>
+                      <a:headEnd type="none" w="med" len="med"/>
+                      <a:tailEnd type="none" w="med" len="med"/>
+                    </a:lnR>
+                    <a:lnT w="12700" cap="flat" cmpd="sng" algn="ctr">
+                      <a:solidFill>
+                        <a:srgbClr val="DDE3E0"/>
+                      </a:solidFill>
+                      <a:prstDash val="solid"/>
+                      <a:round/>
+                      <a:headEnd type="none" w="med" len="med"/>
+                      <a:tailEnd type="none" w="med" len="med"/>
+                    </a:lnT>
+                    <a:lnB w="12700" cap="flat" cmpd="sng" algn="ctr">
+                      <a:solidFill>
+                        <a:srgbClr val="DDE3E0"/>
+                      </a:solidFill>
+                      <a:prstDash val="solid"/>
+                      <a:round/>
+                      <a:headEnd type="none" w="med" len="med"/>
+                      <a:tailEnd type="none" w="med" len="med"/>
+                    </a:lnB>
+                    <a:solidFill>
+                      <a:schemeClr val="bg1"/>
+                    </a:solidFill>
+                  </a:tcPr>
+                </a:tc>
+                <a:tc>
+                  <a:txBody>
+                    <a:bodyPr/>
+                    <a:lstStyle/>
+                    <a:p>
+                      <a:pPr indent="0" marL="0">
+                        <a:buNone/>
+                      </a:pPr>
+                      <a:r>
+                        <a:rPr lang="en-US" sz="3200" b="1" dirty="0">
+                          <a:solidFill>
+                            <a:schemeClr val="tx1"/>
+                          </a:solidFill>
+                          <a:latin typeface="Courier New" pitchFamily="34" charset="0"/>
+                          <a:ea typeface="Courier New" pitchFamily="34" charset="-122"/>
+                          <a:cs typeface="Courier New" pitchFamily="34" charset="-120"/>
+                        </a:rPr>
+                        <a:t>failed_rules</a:t>
+                      </a:r>
+                      <a:endParaRPr lang="en-US" sz="3200" dirty="0">
+                        <a:latin typeface="Courier New" charset="0"/>
+                        <a:ea typeface="Courier New" charset="0"/>
+                        <a:cs typeface="Courier New" charset="0"/>
+                      </a:endParaRPr>
+                    </a:p>
+                  </a:txBody>
+                  <a:tcPr marL="109728" marR="109728" marT="54864" marB="54864" anchor="ctr">
+                    <a:lnL w="12700" cap="flat" cmpd="sng" algn="ctr">
+                      <a:solidFill>
+                        <a:srgbClr val="DDE3E0"/>
+                      </a:solidFill>
+                      <a:prstDash val="solid"/>
+                      <a:round/>
+                      <a:headEnd type="none" w="med" len="med"/>
+                      <a:tailEnd type="none" w="med" len="med"/>
+                    </a:lnL>
+                    <a:lnR w="12700" cap="flat" cmpd="sng" algn="ctr">
+                      <a:solidFill>
+                        <a:srgbClr val="DDE3E0"/>
+                      </a:solidFill>
+                      <a:prstDash val="solid"/>
+                      <a:round/>
+                      <a:headEnd type="none" w="med" len="med"/>
+                      <a:tailEnd type="none" w="med" len="med"/>
+                    </a:lnR>
+                    <a:lnT w="12700" cap="flat" cmpd="sng" algn="ctr">
+                      <a:solidFill>
+                        <a:srgbClr val="DDE3E0"/>
+                      </a:solidFill>
+                      <a:prstDash val="solid"/>
+                      <a:round/>
+                      <a:headEnd type="none" w="med" len="med"/>
+                      <a:tailEnd type="none" w="med" len="med"/>
+                    </a:lnT>
+                    <a:lnB w="12700" cap="flat" cmpd="sng" algn="ctr">
+                      <a:solidFill>
+                        <a:srgbClr val="DDE3E0"/>
+                      </a:solidFill>
+                      <a:prstDash val="solid"/>
+                      <a:round/>
+                      <a:headEnd type="none" w="med" len="med"/>
+                      <a:tailEnd type="none" w="med" len="med"/>
+                    </a:lnB>
+                    <a:solidFill>
+                      <a:schemeClr val="bg1"/>
+                    </a:solidFill>
+                  </a:tcPr>
+                </a:tc>
+                <a:tc>
+                  <a:txBody>
+                    <a:bodyPr/>
+                    <a:lstStyle/>
+                    <a:p>
+                      <a:pPr indent="0" marL="0">
+                        <a:buNone/>
+                      </a:pPr>
+                      <a:r>
+                        <a:rPr lang="en-US" sz="3200" b="1" dirty="0">
+                          <a:solidFill>
+                            <a:schemeClr val="tx1"/>
+                          </a:solidFill>
+                          <a:latin typeface="Courier New" pitchFamily="34" charset="0"/>
+                          <a:ea typeface="Courier New" pitchFamily="34" charset="-122"/>
+                          <a:cs typeface="Courier New" pitchFamily="34" charset="-120"/>
+                        </a:rPr>
+                        <a:t>notes</a:t>
+                      </a:r>
+                      <a:endParaRPr lang="en-US" sz="3200" dirty="0">
+                        <a:latin typeface="Courier New" charset="0"/>
+                        <a:ea typeface="Courier New" charset="0"/>
+                        <a:cs typeface="Courier New" charset="0"/>
+                      </a:endParaRPr>
+                    </a:p>
+                  </a:txBody>
+                  <a:tcPr marL="109728" marR="109728" marT="54864" marB="54864" anchor="ctr">
+                    <a:lnL w="12700" cap="flat" cmpd="sng" algn="ctr">
+                      <a:solidFill>
+                        <a:srgbClr val="DDE3E0"/>
+                      </a:solidFill>
+                      <a:prstDash val="solid"/>
+                      <a:round/>
+                      <a:headEnd type="none" w="med" len="med"/>
+                      <a:tailEnd type="none" w="med" len="med"/>
+                    </a:lnL>
+                    <a:lnR w="12700" cap="flat" cmpd="sng" algn="ctr">
+                      <a:solidFill>
+                        <a:srgbClr val="DDE3E0"/>
+                      </a:solidFill>
+                      <a:prstDash val="solid"/>
+                      <a:round/>
+                      <a:headEnd type="none" w="med" len="med"/>
+                      <a:tailEnd type="none" w="med" len="med"/>
+                    </a:lnR>
+                    <a:lnT w="12700" cap="flat" cmpd="sng" algn="ctr">
+                      <a:solidFill>
+                        <a:srgbClr val="DDE3E0"/>
+                      </a:solidFill>
+                      <a:prstDash val="solid"/>
+                      <a:round/>
+                      <a:headEnd type="none" w="med" len="med"/>
+                      <a:tailEnd type="none" w="med" len="med"/>
+                    </a:lnT>
+                    <a:lnB w="12700" cap="flat" cmpd="sng" algn="ctr">
+                      <a:solidFill>
+                        <a:srgbClr val="DDE3E0"/>
+                      </a:solidFill>
+                      <a:prstDash val="solid"/>
+                      <a:round/>
+                      <a:headEnd type="none" w="med" len="med"/>
+                      <a:tailEnd type="none" w="med" len="med"/>
+                    </a:lnB>
+                    <a:solidFill>
+                      <a:schemeClr val="bg1"/>
+                    </a:solidFill>
+                  </a:tcPr>
+                </a:tc>
+              </a:tr>
+              <a:tr h="0">
+                <a:tc>
+                  <a:txBody>
+                    <a:bodyPr/>
+                    <a:lstStyle/>
+                    <a:p>
+                      <a:pPr indent="0" marL="0">
+                        <a:buNone/>
+                      </a:pPr>
+                      <a:r>
+                        <a:rPr lang="en-US" sz="3200" dirty="0">
+                          <a:solidFill>
+                            <a:schemeClr val="tx1"/>
+                          </a:solidFill>
+                        </a:rPr>
+                        <a:t>cardiomegaly</a:t>
+                      </a:r>
+                      <a:endParaRPr lang="en-US" sz="3200" dirty="0"/>
+                    </a:p>
+                  </a:txBody>
+                  <a:tcPr marL="109728" marR="109728" marT="54864" marB="54864" anchor="ctr">
+                    <a:lnL w="12700" cap="flat" cmpd="sng" algn="ctr">
+                      <a:solidFill>
+                        <a:srgbClr val="DDE3E0"/>
+                      </a:solidFill>
+                      <a:prstDash val="solid"/>
+                      <a:round/>
+                      <a:headEnd type="none" w="med" len="med"/>
+                      <a:tailEnd type="none" w="med" len="med"/>
+                    </a:lnL>
+                    <a:lnR w="12700" cap="flat" cmpd="sng" algn="ctr">
+                      <a:solidFill>
+                        <a:srgbClr val="DDE3E0"/>
+                      </a:solidFill>
+                      <a:prstDash val="solid"/>
+                      <a:round/>
+                      <a:headEnd type="none" w="med" len="med"/>
+                      <a:tailEnd type="none" w="med" len="med"/>
+                    </a:lnR>
+                    <a:lnT w="12700" cap="flat" cmpd="sng" algn="ctr">
+                      <a:solidFill>
+                        <a:srgbClr val="DDE3E0"/>
+                      </a:solidFill>
+                      <a:prstDash val="solid"/>
+                      <a:round/>
+                      <a:headEnd type="none" w="med" len="med"/>
+                      <a:tailEnd type="none" w="med" len="med"/>
+                    </a:lnT>
+                    <a:lnB w="12700" cap="flat" cmpd="sng" algn="ctr">
+                      <a:solidFill>
+                        <a:srgbClr val="DDE3E0"/>
+                      </a:solidFill>
+                      <a:prstDash val="solid"/>
+                      <a:round/>
+                      <a:headEnd type="none" w="med" len="med"/>
+                      <a:tailEnd type="none" w="med" len="med"/>
+                    </a:lnB>
+                    <a:solidFill>
+                      <a:schemeClr val="bg1"/>
+                    </a:solidFill>
+                  </a:tcPr>
+                </a:tc>
+                <a:tc>
+                  <a:txBody>
+                    <a:bodyPr/>
+                    <a:lstStyle/>
+                    <a:p>
+                      <a:pPr indent="0" marL="0">
+                        <a:buNone/>
+                      </a:pPr>
+                      <a:r>
+                        <a:rPr lang="en-US" sz="3200" b="1" dirty="0">
+                          <a:solidFill>
+                            <a:schemeClr val="accent1"/>
+                          </a:solidFill>
+                        </a:rPr>
+                        <a:t>approved</a:t>
+                      </a:r>
+                      <a:endParaRPr lang="en-US" sz="3200" dirty="0"/>
+                    </a:p>
+                  </a:txBody>
+                  <a:tcPr marL="109728" marR="109728" marT="54864" marB="54864" anchor="ctr">
+                    <a:lnL w="12700" cap="flat" cmpd="sng" algn="ctr">
+                      <a:solidFill>
+                        <a:srgbClr val="DDE3E0"/>
+                      </a:solidFill>
+                      <a:prstDash val="solid"/>
+                      <a:round/>
+                      <a:headEnd type="none" w="med" len="med"/>
+                      <a:tailEnd type="none" w="med" len="med"/>
+                    </a:lnL>
+                    <a:lnR w="12700" cap="flat" cmpd="sng" algn="ctr">
+                      <a:solidFill>
+                        <a:srgbClr val="DDE3E0"/>
+                      </a:solidFill>
+                      <a:prstDash val="solid"/>
+                      <a:round/>
+                      <a:headEnd type="none" w="med" len="med"/>
+                      <a:tailEnd type="none" w="med" len="med"/>
+                    </a:lnR>
+                    <a:lnT w="12700" cap="flat" cmpd="sng" algn="ctr">
+                      <a:solidFill>
+                        <a:srgbClr val="DDE3E0"/>
+                      </a:solidFill>
+                      <a:prstDash val="solid"/>
+                      <a:round/>
+                      <a:headEnd type="none" w="med" len="med"/>
+                      <a:tailEnd type="none" w="med" len="med"/>
+                    </a:lnT>
+                    <a:lnB w="12700" cap="flat" cmpd="sng" algn="ctr">
+                      <a:solidFill>
+                        <a:srgbClr val="DDE3E0"/>
+                      </a:solidFill>
+                      <a:prstDash val="solid"/>
+                      <a:round/>
+                      <a:headEnd type="none" w="med" len="med"/>
+                      <a:tailEnd type="none" w="med" len="med"/>
+                    </a:lnB>
+                    <a:solidFill>
+                      <a:schemeClr val="bg1"/>
+                    </a:solidFill>
+                  </a:tcPr>
+                </a:tc>
+                <a:tc>
+                  <a:txBody>
+                    <a:bodyPr/>
+                    <a:lstStyle/>
+                    <a:p>
+                      <a:pPr indent="0" marL="0">
+                        <a:buNone/>
+                      </a:pPr>
+                      <a:r>
+                        <a:rPr lang="en-US" sz="3200" dirty="0">
+                          <a:solidFill>
+                            <a:schemeClr val="tx1"/>
+                          </a:solidFill>
+                        </a:rPr>
+                        <a:t>none</a:t>
+                      </a:r>
+                      <a:endParaRPr lang="en-US" sz="3200" dirty="0"/>
+                    </a:p>
+                  </a:txBody>
+                  <a:tcPr marL="109728" marR="109728" marT="54864" marB="54864" anchor="ctr">
+                    <a:lnL w="12700" cap="flat" cmpd="sng" algn="ctr">
+                      <a:solidFill>
+                        <a:srgbClr val="DDE3E0"/>
+                      </a:solidFill>
+                      <a:prstDash val="solid"/>
+                      <a:round/>
+                      <a:headEnd type="none" w="med" len="med"/>
+                      <a:tailEnd type="none" w="med" len="med"/>
+                    </a:lnL>
+                    <a:lnR w="12700" cap="flat" cmpd="sng" algn="ctr">
+                      <a:solidFill>
+                        <a:srgbClr val="DDE3E0"/>
+                      </a:solidFill>
+                      <a:prstDash val="solid"/>
+                      <a:round/>
+                      <a:headEnd type="none" w="med" len="med"/>
+                      <a:tailEnd type="none" w="med" len="med"/>
+                    </a:lnR>
+                    <a:lnT w="12700" cap="flat" cmpd="sng" algn="ctr">
+                      <a:solidFill>
+                        <a:srgbClr val="DDE3E0"/>
+                      </a:solidFill>
+                      <a:prstDash val="solid"/>
+                      <a:round/>
+                      <a:headEnd type="none" w="med" len="med"/>
+                      <a:tailEnd type="none" w="med" len="med"/>
+                    </a:lnT>
+                    <a:lnB w="12700" cap="flat" cmpd="sng" algn="ctr">
+                      <a:solidFill>
+                        <a:srgbClr val="DDE3E0"/>
+                      </a:solidFill>
+                      <a:prstDash val="solid"/>
+                      <a:round/>
+                      <a:headEnd type="none" w="med" len="med"/>
+                      <a:tailEnd type="none" w="med" len="med"/>
+                    </a:lnB>
+                    <a:solidFill>
+                      <a:schemeClr val="bg1"/>
+                    </a:solidFill>
+                  </a:tcPr>
+                </a:tc>
+                <a:tc>
+                  <a:txBody>
+                    <a:bodyPr/>
+                    <a:lstStyle/>
+                    <a:p>
+                      <a:pPr indent="0" marL="0">
+                        <a:buNone/>
+                      </a:pPr>
+                      <a:r>
+                        <a:rPr lang="en-US" sz="3200" dirty="0">
+                          <a:solidFill>
+                            <a:schemeClr val="tx1"/>
+                          </a:solidFill>
+                        </a:rPr>
+                        <a:t>none</a:t>
+                      </a:r>
+                      <a:endParaRPr lang="en-US" sz="3200" dirty="0"/>
+                    </a:p>
+                  </a:txBody>
+                  <a:tcPr marL="109728" marR="109728" marT="54864" marB="54864" anchor="ctr">
+                    <a:lnL w="12700" cap="flat" cmpd="sng" algn="ctr">
+                      <a:solidFill>
+                        <a:srgbClr val="DDE3E0"/>
+                      </a:solidFill>
+                      <a:prstDash val="solid"/>
+                      <a:round/>
+                      <a:headEnd type="none" w="med" len="med"/>
+                      <a:tailEnd type="none" w="med" len="med"/>
+                    </a:lnL>
+                    <a:lnR w="12700" cap="flat" cmpd="sng" algn="ctr">
+                      <a:solidFill>
+                        <a:srgbClr val="DDE3E0"/>
+                      </a:solidFill>
+                      <a:prstDash val="solid"/>
+                      <a:round/>
+                      <a:headEnd type="none" w="med" len="med"/>
+                      <a:tailEnd type="none" w="med" len="med"/>
+                    </a:lnR>
+                    <a:lnT w="12700" cap="flat" cmpd="sng" algn="ctr">
+                      <a:solidFill>
+                        <a:srgbClr val="DDE3E0"/>
+                      </a:solidFill>
+                      <a:prstDash val="solid"/>
+                      <a:round/>
+                      <a:headEnd type="none" w="med" len="med"/>
+                      <a:tailEnd type="none" w="med" len="med"/>
+                    </a:lnT>
+                    <a:lnB w="12700" cap="flat" cmpd="sng" algn="ctr">
+                      <a:solidFill>
+                        <a:srgbClr val="DDE3E0"/>
+                      </a:solidFill>
+                      <a:prstDash val="solid"/>
+                      <a:round/>
+                      <a:headEnd type="none" w="med" len="med"/>
+                      <a:tailEnd type="none" w="med" len="med"/>
+                    </a:lnB>
+                    <a:solidFill>
+                      <a:schemeClr val="bg1"/>
+                    </a:solidFill>
+                  </a:tcPr>
+                </a:tc>
+              </a:tr>
+              <a:tr h="0">
+                <a:tc>
+                  <a:txBody>
+                    <a:bodyPr/>
+                    <a:lstStyle/>
+                    <a:p>
+                      <a:pPr indent="0" marL="0">
+                        <a:buNone/>
+                      </a:pPr>
+                      <a:r>
+                        <a:rPr lang="en-US" sz="3200" dirty="0">
+                          <a:solidFill>
+                            <a:schemeClr val="tx1"/>
+                          </a:solidFill>
+                        </a:rPr>
+                        <a:t>atelectasis</a:t>
+                      </a:r>
+                      <a:endParaRPr lang="en-US" sz="3200" dirty="0"/>
+                    </a:p>
+                  </a:txBody>
+                  <a:tcPr marL="109728" marR="109728" marT="54864" marB="54864" anchor="ctr">
+                    <a:lnL w="12700" cap="flat" cmpd="sng" algn="ctr">
+                      <a:solidFill>
+                        <a:srgbClr val="DDE3E0"/>
+                      </a:solidFill>
+                      <a:prstDash val="solid"/>
+                      <a:round/>
+                      <a:headEnd type="none" w="med" len="med"/>
+                      <a:tailEnd type="none" w="med" len="med"/>
+                    </a:lnL>
+                    <a:lnR w="12700" cap="flat" cmpd="sng" algn="ctr">
+                      <a:solidFill>
+                        <a:srgbClr val="DDE3E0"/>
+                      </a:solidFill>
+                      <a:prstDash val="solid"/>
+                      <a:round/>
+                      <a:headEnd type="none" w="med" len="med"/>
+                      <a:tailEnd type="none" w="med" len="med"/>
+                    </a:lnR>
+                    <a:lnT w="12700" cap="flat" cmpd="sng" algn="ctr">
+                      <a:solidFill>
+                        <a:srgbClr val="DDE3E0"/>
+                      </a:solidFill>
+                      <a:prstDash val="solid"/>
+                      <a:round/>
+                      <a:headEnd type="none" w="med" len="med"/>
+                      <a:tailEnd type="none" w="med" len="med"/>
+                    </a:lnT>
+                    <a:lnB w="12700" cap="flat" cmpd="sng" algn="ctr">
+                      <a:solidFill>
+                        <a:srgbClr val="DDE3E0"/>
+                      </a:solidFill>
+                      <a:prstDash val="solid"/>
+                      <a:round/>
+                      <a:headEnd type="none" w="med" len="med"/>
+                      <a:tailEnd type="none" w="med" len="med"/>
+                    </a:lnB>
+                    <a:solidFill>
+                      <a:schemeClr val="bg1"/>
+                    </a:solidFill>
+                  </a:tcPr>
+                </a:tc>
+                <a:tc>
+                  <a:txBody>
+                    <a:bodyPr/>
+                    <a:lstStyle/>
+                    <a:p>
+                      <a:pPr indent="0" marL="0">
+                        <a:buNone/>
+                      </a:pPr>
+                      <a:r>
+                        <a:rPr lang="en-US" sz="3200" dirty="0">
+                          <a:solidFill>
+                            <a:schemeClr val="tx1"/>
+                          </a:solidFill>
+                        </a:rPr>
+                        <a:t>corrected</a:t>
+                      </a:r>
+                      <a:endParaRPr lang="en-US" sz="3200" dirty="0"/>
+                    </a:p>
+                  </a:txBody>
+                  <a:tcPr marL="109728" marR="109728" marT="54864" marB="54864" anchor="ctr">
+                    <a:lnL w="12700" cap="flat" cmpd="sng" algn="ctr">
+                      <a:solidFill>
+                        <a:srgbClr val="DDE3E0"/>
+                      </a:solidFill>
+                      <a:prstDash val="solid"/>
+                      <a:round/>
+                      <a:headEnd type="none" w="med" len="med"/>
+                      <a:tailEnd type="none" w="med" len="med"/>
+                    </a:lnL>
+                    <a:lnR w="12700" cap="flat" cmpd="sng" algn="ctr">
+                      <a:solidFill>
+                        <a:srgbClr val="DDE3E0"/>
+                      </a:solidFill>
+                      <a:prstDash val="solid"/>
+                      <a:round/>
+                      <a:headEnd type="none" w="med" len="med"/>
+                      <a:tailEnd type="none" w="med" len="med"/>
+                    </a:lnR>
+                    <a:lnT w="12700" cap="flat" cmpd="sng" algn="ctr">
+                      <a:solidFill>
+                        <a:srgbClr val="DDE3E0"/>
+                      </a:solidFill>
+                      <a:prstDash val="solid"/>
+                      <a:round/>
+                      <a:headEnd type="none" w="med" len="med"/>
+                      <a:tailEnd type="none" w="med" len="med"/>
+                    </a:lnT>
+                    <a:lnB w="12700" cap="flat" cmpd="sng" algn="ctr">
+                      <a:solidFill>
+                        <a:srgbClr val="DDE3E0"/>
+                      </a:solidFill>
+                      <a:prstDash val="solid"/>
+                      <a:round/>
+                      <a:headEnd type="none" w="med" len="med"/>
+                      <a:tailEnd type="none" w="med" len="med"/>
+                    </a:lnB>
+                    <a:solidFill>
+                      <a:schemeClr val="bg1"/>
+                    </a:solidFill>
+                  </a:tcPr>
+                </a:tc>
+                <a:tc>
+                  <a:txBody>
+                    <a:bodyPr/>
+                    <a:lstStyle/>
+                    <a:p>
+                      <a:pPr indent="0" marL="0">
+                        <a:buNone/>
+                      </a:pPr>
+                      <a:r>
+                        <a:rPr lang="en-US" sz="3200" dirty="0">
+                          <a:solidFill>
+                            <a:schemeClr val="tx1"/>
+                          </a:solidFill>
+                        </a:rPr>
+                        <a:t>1</a:t>
+                      </a:r>
+                      <a:endParaRPr lang="en-US" sz="3200" dirty="0"/>
+                    </a:p>
+                  </a:txBody>
+                  <a:tcPr marL="109728" marR="109728" marT="54864" marB="54864" anchor="ctr">
+                    <a:lnL w="12700" cap="flat" cmpd="sng" algn="ctr">
+                      <a:solidFill>
+                        <a:srgbClr val="DDE3E0"/>
+                      </a:solidFill>
+                      <a:prstDash val="solid"/>
+                      <a:round/>
+                      <a:headEnd type="none" w="med" len="med"/>
+                      <a:tailEnd type="none" w="med" len="med"/>
+                    </a:lnL>
+                    <a:lnR w="12700" cap="flat" cmpd="sng" algn="ctr">
+                      <a:solidFill>
+                        <a:srgbClr val="DDE3E0"/>
+                      </a:solidFill>
+                      <a:prstDash val="solid"/>
+                      <a:round/>
+                      <a:headEnd type="none" w="med" len="med"/>
+                      <a:tailEnd type="none" w="med" len="med"/>
+                    </a:lnR>
+                    <a:lnT w="12700" cap="flat" cmpd="sng" algn="ctr">
+                      <a:solidFill>
+                        <a:srgbClr val="DDE3E0"/>
+                      </a:solidFill>
+                      <a:prstDash val="solid"/>
+                      <a:round/>
+                      <a:headEnd type="none" w="med" len="med"/>
+                      <a:tailEnd type="none" w="med" len="med"/>
+                    </a:lnT>
+                    <a:lnB w="12700" cap="flat" cmpd="sng" algn="ctr">
+                      <a:solidFill>
+                        <a:srgbClr val="DDE3E0"/>
+                      </a:solidFill>
+                      <a:prstDash val="solid"/>
+                      <a:round/>
+                      <a:headEnd type="none" w="med" len="med"/>
+                      <a:tailEnd type="none" w="med" len="med"/>
+                    </a:lnB>
+                    <a:solidFill>
+                      <a:schemeClr val="bg1"/>
+                    </a:solidFill>
+                  </a:tcPr>
+                </a:tc>
+                <a:tc>
+                  <a:txBody>
+                    <a:bodyPr/>
+                    <a:lstStyle/>
+                    <a:p>
+                      <a:pPr indent="0" marL="0">
+                        <a:buNone/>
+                      </a:pPr>
+                      <a:r>
+                        <a:rPr lang="en-US" sz="3200" dirty="0">
+                          <a:solidFill>
+                            <a:schemeClr val="tx1"/>
+                          </a:solidFill>
+                        </a:rPr>
+                        <a:t>“Named a cause”</a:t>
+                      </a:r>
+                      <a:endParaRPr lang="en-US" sz="3200" dirty="0"/>
+                    </a:p>
+                  </a:txBody>
+                  <a:tcPr marL="109728" marR="109728" marT="54864" marB="54864" anchor="ctr">
+                    <a:lnL w="12700" cap="flat" cmpd="sng" algn="ctr">
+                      <a:solidFill>
+                        <a:srgbClr val="DDE3E0"/>
+                      </a:solidFill>
+                      <a:prstDash val="solid"/>
+                      <a:round/>
+                      <a:headEnd type="none" w="med" len="med"/>
+                      <a:tailEnd type="none" w="med" len="med"/>
+                    </a:lnL>
+                    <a:lnR w="12700" cap="flat" cmpd="sng" algn="ctr">
+                      <a:solidFill>
+                        <a:srgbClr val="DDE3E0"/>
+                      </a:solidFill>
+                      <a:prstDash val="solid"/>
+                      <a:round/>
+                      <a:headEnd type="none" w="med" len="med"/>
+                      <a:tailEnd type="none" w="med" len="med"/>
+                    </a:lnR>
+                    <a:lnT w="12700" cap="flat" cmpd="sng" algn="ctr">
+                      <a:solidFill>
+                        <a:srgbClr val="DDE3E0"/>
+                      </a:solidFill>
+                      <a:prstDash val="solid"/>
+                      <a:round/>
+                      <a:headEnd type="none" w="med" len="med"/>
+                      <a:tailEnd type="none" w="med" len="med"/>
+                    </a:lnT>
+                    <a:lnB w="12700" cap="flat" cmpd="sng" algn="ctr">
+                      <a:solidFill>
+                        <a:srgbClr val="DDE3E0"/>
+                      </a:solidFill>
+                      <a:prstDash val="solid"/>
+                      <a:round/>
+                      <a:headEnd type="none" w="med" len="med"/>
+                      <a:tailEnd type="none" w="med" len="med"/>
+                    </a:lnB>
+                    <a:solidFill>
+                      <a:schemeClr val="bg1"/>
+                    </a:solidFill>
+                  </a:tcPr>
+                </a:tc>
+              </a:tr>
+              <a:tr h="0">
+                <a:tc>
+                  <a:txBody>
+                    <a:bodyPr/>
+                    <a:lstStyle/>
+                    <a:p>
+                      <a:pPr indent="0" marL="0">
+                        <a:buNone/>
+                      </a:pPr>
+                      <a:r>
+                        <a:rPr lang="en-US" sz="3200" dirty="0">
+                          <a:solidFill>
+                            <a:schemeClr val="tx1"/>
+                          </a:solidFill>
+                        </a:rPr>
+                        <a:t>pleural effusion</a:t>
+                      </a:r>
+                      <a:endParaRPr lang="en-US" sz="3200" dirty="0"/>
+                    </a:p>
+                  </a:txBody>
+                  <a:tcPr marL="109728" marR="109728" marT="54864" marB="54864" anchor="ctr">
+                    <a:lnL w="12700" cap="flat" cmpd="sng" algn="ctr">
+                      <a:solidFill>
+                        <a:srgbClr val="DDE3E0"/>
+                      </a:solidFill>
+                      <a:prstDash val="solid"/>
+                      <a:round/>
+                      <a:headEnd type="none" w="med" len="med"/>
+                      <a:tailEnd type="none" w="med" len="med"/>
+                    </a:lnL>
+                    <a:lnR w="12700" cap="flat" cmpd="sng" algn="ctr">
+                      <a:solidFill>
+                        <a:srgbClr val="DDE3E0"/>
+                      </a:solidFill>
+                      <a:prstDash val="solid"/>
+                      <a:round/>
+                      <a:headEnd type="none" w="med" len="med"/>
+                      <a:tailEnd type="none" w="med" len="med"/>
+                    </a:lnR>
+                    <a:lnT w="12700" cap="flat" cmpd="sng" algn="ctr">
+                      <a:solidFill>
+                        <a:srgbClr val="DDE3E0"/>
+                      </a:solidFill>
+                      <a:prstDash val="solid"/>
+                      <a:round/>
+                      <a:headEnd type="none" w="med" len="med"/>
+                      <a:tailEnd type="none" w="med" len="med"/>
+                    </a:lnT>
+                    <a:lnB w="12700" cap="flat" cmpd="sng" algn="ctr">
+                      <a:solidFill>
+                        <a:srgbClr val="DDE3E0"/>
+                      </a:solidFill>
+                      <a:prstDash val="solid"/>
+                      <a:round/>
+                      <a:headEnd type="none" w="med" len="med"/>
+                      <a:tailEnd type="none" w="med" len="med"/>
+                    </a:lnB>
+                    <a:solidFill>
+                      <a:schemeClr val="bg1"/>
+                    </a:solidFill>
+                  </a:tcPr>
+                </a:tc>
+                <a:tc>
+                  <a:txBody>
+                    <a:bodyPr/>
+                    <a:lstStyle/>
+                    <a:p>
+                      <a:pPr indent="0" marL="0">
+                        <a:buNone/>
+                      </a:pPr>
+                      <a:r>
+                        <a:rPr lang="en-US" sz="3200" b="1" dirty="0">
+                          <a:solidFill>
+                            <a:schemeClr val="accent2"/>
+                          </a:solidFill>
+                        </a:rPr>
+                        <a:t>failed</a:t>
+                      </a:r>
+                      <a:endParaRPr lang="en-US" sz="3200" dirty="0"/>
+                    </a:p>
+                  </a:txBody>
+                  <a:tcPr marL="109728" marR="109728" marT="54864" marB="54864" anchor="ctr">
+                    <a:lnL w="12700" cap="flat" cmpd="sng" algn="ctr">
+                      <a:solidFill>
+                        <a:srgbClr val="DDE3E0"/>
+                      </a:solidFill>
+                      <a:prstDash val="solid"/>
+                      <a:round/>
+                      <a:headEnd type="none" w="med" len="med"/>
+                      <a:tailEnd type="none" w="med" len="med"/>
+                    </a:lnL>
+                    <a:lnR w="12700" cap="flat" cmpd="sng" algn="ctr">
+                      <a:solidFill>
+                        <a:srgbClr val="DDE3E0"/>
+                      </a:solidFill>
+                      <a:prstDash val="solid"/>
+                      <a:round/>
+                      <a:headEnd type="none" w="med" len="med"/>
+                      <a:tailEnd type="none" w="med" len="med"/>
+                    </a:lnR>
+                    <a:lnT w="12700" cap="flat" cmpd="sng" algn="ctr">
+                      <a:solidFill>
+                        <a:srgbClr val="DDE3E0"/>
+                      </a:solidFill>
+                      <a:prstDash val="solid"/>
+                      <a:round/>
+                      <a:headEnd type="none" w="med" len="med"/>
+                      <a:tailEnd type="none" w="med" len="med"/>
+                    </a:lnT>
+                    <a:lnB w="12700" cap="flat" cmpd="sng" algn="ctr">
+                      <a:solidFill>
+                        <a:srgbClr val="DDE3E0"/>
+                      </a:solidFill>
+                      <a:prstDash val="solid"/>
+                      <a:round/>
+                      <a:headEnd type="none" w="med" len="med"/>
+                      <a:tailEnd type="none" w="med" len="med"/>
+                    </a:lnB>
+                    <a:solidFill>
+                      <a:schemeClr val="bg1"/>
+                    </a:solidFill>
+                  </a:tcPr>
+                </a:tc>
+                <a:tc>
+                  <a:txBody>
+                    <a:bodyPr/>
+                    <a:lstStyle/>
+                    <a:p>
+                      <a:pPr indent="0" marL="0">
+                        <a:buNone/>
+                      </a:pPr>
+                      <a:r>
+                        <a:rPr lang="en-US" sz="3200" dirty="0">
+                          <a:solidFill>
+                            <a:schemeClr val="tx1"/>
+                          </a:solidFill>
+                        </a:rPr>
+                        <a:t>1</a:t>
+                      </a:r>
+                      <a:endParaRPr lang="en-US" sz="3200" dirty="0"/>
+                    </a:p>
+                  </a:txBody>
+                  <a:tcPr marL="109728" marR="109728" marT="54864" marB="54864" anchor="ctr">
+                    <a:lnL w="12700" cap="flat" cmpd="sng" algn="ctr">
+                      <a:solidFill>
+                        <a:srgbClr val="DDE3E0"/>
+                      </a:solidFill>
+                      <a:prstDash val="solid"/>
+                      <a:round/>
+                      <a:headEnd type="none" w="med" len="med"/>
+                      <a:tailEnd type="none" w="med" len="med"/>
+                    </a:lnL>
+                    <a:lnR w="12700" cap="flat" cmpd="sng" algn="ctr">
+                      <a:solidFill>
+                        <a:srgbClr val="DDE3E0"/>
+                      </a:solidFill>
+                      <a:prstDash val="solid"/>
+                      <a:round/>
+                      <a:headEnd type="none" w="med" len="med"/>
+                      <a:tailEnd type="none" w="med" len="med"/>
+                    </a:lnR>
+                    <a:lnT w="12700" cap="flat" cmpd="sng" algn="ctr">
+                      <a:solidFill>
+                        <a:srgbClr val="DDE3E0"/>
+                      </a:solidFill>
+                      <a:prstDash val="solid"/>
+                      <a:round/>
+                      <a:headEnd type="none" w="med" len="med"/>
+                      <a:tailEnd type="none" w="med" len="med"/>
+                    </a:lnT>
+                    <a:lnB w="12700" cap="flat" cmpd="sng" algn="ctr">
+                      <a:solidFill>
+                        <a:srgbClr val="DDE3E0"/>
+                      </a:solidFill>
+                      <a:prstDash val="solid"/>
+                      <a:round/>
+                      <a:headEnd type="none" w="med" len="med"/>
+                      <a:tailEnd type="none" w="med" len="med"/>
+                    </a:lnB>
+                    <a:solidFill>
+                      <a:schemeClr val="bg1"/>
+                    </a:solidFill>
+                  </a:tcPr>
+                </a:tc>
+                <a:tc>
+                  <a:txBody>
+                    <a:bodyPr/>
+                    <a:lstStyle/>
+                    <a:p>
+                      <a:pPr indent="0" marL="0">
+                        <a:buNone/>
+                      </a:pPr>
+                      <a:r>
+                        <a:rPr lang="en-US" sz="3200" dirty="0">
+                          <a:solidFill>
+                            <a:schemeClr val="tx1"/>
+                          </a:solidFill>
+                        </a:rPr>
+                        <a:t>“Predicted an outcome”</a:t>
+                      </a:r>
+                      <a:endParaRPr lang="en-US" sz="3200" dirty="0"/>
+                    </a:p>
+                  </a:txBody>
+                  <a:tcPr marL="109728" marR="109728" marT="54864" marB="54864" anchor="ctr">
+                    <a:lnL w="12700" cap="flat" cmpd="sng" algn="ctr">
+                      <a:solidFill>
+                        <a:srgbClr val="DDE3E0"/>
+                      </a:solidFill>
+                      <a:prstDash val="solid"/>
+                      <a:round/>
+                      <a:headEnd type="none" w="med" len="med"/>
+                      <a:tailEnd type="none" w="med" len="med"/>
+                    </a:lnL>
+                    <a:lnR w="12700" cap="flat" cmpd="sng" algn="ctr">
+                      <a:solidFill>
+                        <a:srgbClr val="DDE3E0"/>
+                      </a:solidFill>
+                      <a:prstDash val="solid"/>
+                      <a:round/>
+                      <a:headEnd type="none" w="med" len="med"/>
+                      <a:tailEnd type="none" w="med" len="med"/>
+                    </a:lnR>
+                    <a:lnT w="12700" cap="flat" cmpd="sng" algn="ctr">
+                      <a:solidFill>
+                        <a:srgbClr val="DDE3E0"/>
+                      </a:solidFill>
+                      <a:prstDash val="solid"/>
+                      <a:round/>
+                      <a:headEnd type="none" w="med" len="med"/>
+                      <a:tailEnd type="none" w="med" len="med"/>
+                    </a:lnT>
+                    <a:lnB w="12700" cap="flat" cmpd="sng" algn="ctr">
+                      <a:solidFill>
+                        <a:srgbClr val="DDE3E0"/>
+                      </a:solidFill>
+                      <a:prstDash val="solid"/>
+                      <a:round/>
+                      <a:headEnd type="none" w="med" len="med"/>
+                      <a:tailEnd type="none" w="med" len="med"/>
+                    </a:lnB>
+                    <a:solidFill>
+                      <a:schemeClr val="bg1"/>
+                    </a:solidFill>
+                  </a:tcPr>
+                </a:tc>
+              </a:tr>
+            </a:tbl>
+          </a:graphicData>
+        </a:graphic>
+      </p:graphicFrame>
+      <p:sp>
+        <p:nvSpPr>
+          <p:cNvPr id="5" name="Who can see it"/>
+          <p:cNvSpPr txBox="1"/>
+          <p:nvPr/>
+        </p:nvSpPr>
+        <p:spPr>
+          <a:xfrm>
+            <a:off x="548640" y="5349240"/>
+            <a:ext cx="11094415" cy="502920"/>
+          </a:xfrm>
+          <a:prstGeom prst="rect">
+            <a:avLst/>
+          </a:prstGeom>
+          <a:noFill/>
+          <a:ln/>
+        </p:spPr>
+        <p:txBody>
+          <a:bodyPr wrap="square" lIns="0" tIns="0" rIns="0" bIns="0" rtlCol="0" anchor="ctr"/>
+          <a:lstStyle/>
+          <a:p>
+            <a:pPr indent="0" marL="0">
+              <a:buNone/>
+            </a:pPr>
+            <a:r>
+              <a:rPr lang="en-US" sz="3200" dirty="0">
+                <a:solidFill>
+                  <a:schemeClr val="tx1"/>
+                </a:solidFill>
+              </a:rPr>
+              <a:t>Visitors never see it, only admins</a:t>
+            </a:r>
+            <a:endParaRPr lang="en-US" sz="3200" dirty="0"/>
+          </a:p>
+        </p:txBody>
+      </p:sp>
+    </p:spTree>
+  </p:cSld>
+  <p:clrMapOvr>
+    <a:masterClrMapping/>
+  </p:clrMapOvr>
+</p:sld>
+</file>
+
+<file path=ppt/slides/slide8.xml><?xml version="1.0" encoding="utf-8"?>
+<p:sld xmlns:a="http://schemas.openxmlformats.org/drawingml/2006/main" xmlns:r="http://schemas.openxmlformats.org/officeDocument/2006/relationships" xmlns:p="http://schemas.openxmlformats.org/presentationml/2006/main">
+  <p:cSld name="Slide 8">
+    <p:spTree>
+      <p:nvGrpSpPr>
+        <p:cNvPr id="1" name=""/>
+        <p:cNvGrpSpPr/>
+        <p:nvPr/>
+      </p:nvGrpSpPr>
+      <p:grpSpPr>
+        <a:xfrm>
+          <a:off x="0" y="0"/>
+          <a:ext cx="0" cy="0"/>
+          <a:chOff x="0" y="0"/>
+          <a:chExt cx="0" cy="0"/>
+        </a:xfrm>
+      </p:grpSpPr>
+      <p:sp>
+        <p:nvSpPr>
+          <p:cNvPr id="2" name="Text 0"/>
+          <p:cNvSpPr/>
+          <p:nvPr>
+            <p:ph idx="100" type="title" hasCustomPrompt="1"/>
+          </p:nvPr>
+        </p:nvSpPr>
+        <p:spPr>
+          <a:xfrm>
+            <a:off x="548640" y="411480"/>
+            <a:ext cx="11094415" cy="731520"/>
+          </a:xfrm>
+          <a:prstGeom prst="rect">
+            <a:avLst/>
+          </a:prstGeom>
+          <a:noFill/>
+          <a:ln/>
+        </p:spPr>
+        <p:txBody>
+          <a:bodyPr wrap="square" lIns="0" tIns="0" rIns="0" bIns="0" rtlCol="0" anchor="ctr"/>
+          <a:lstStyle/>
+          <a:p>
+            <a:pPr indent="0" marL="0">
+              <a:buNone/>
+            </a:pPr>
+            <a:r>
+              <a:rPr lang="en-US" sz="4000" b="1" dirty="0">
+                <a:solidFill>
+                  <a:schemeClr val="tx1"/>
+                </a:solidFill>
+              </a:rPr>
               <a:t>Try it: a reviewed answer in seconds</a:t>
             </a:r>
             <a:endParaRPr lang="en-US" sz="4000" dirty="0"/>

</xml_diff>